<commit_message>
feat: update reconciliation pipeline, pptx annotator, agents and latest input data
</commit_message>
<xml_diff>
--- a/Database/HFPA_Template.pptx
+++ b/Database/HFPA_Template.pptx
@@ -186,9 +186,9 @@
           <c:xMode val="edge"/>
           <c:yMode val="edge"/>
           <c:x val="0.0153254449229824"/>
-          <c:y val="0.289477691612413"/>
+          <c:y val="0.285"/>
           <c:w val="0.978512827732733"/>
-          <c:h val="0.4422616552483"/>
+          <c:h val="0.442"/>
         </c:manualLayout>
       </c:layout>
       <c:barChart>
@@ -225,19 +225,19 @@
               <c:strCache>
                 <c:ptCount val="5"/>
                 <c:pt idx="0">
-                  <c:v>NIKE AIR WINFLO 12 (MS/WS)</c:v>
+                  <c:v>NIKE SB FORCE 58</c:v>
                 </c:pt>
                 <c:pt idx="1">
-                  <c:v>JORDAN SPIZIKE LOW (GS)</c:v>
+                  <c:v>NIKE MANOA LEATHER</c:v>
                 </c:pt>
                 <c:pt idx="2">
-                  <c:v>NIKE SB FORCE 58</c:v>
+                  <c:v>WMNS BENASSI JDI</c:v>
                 </c:pt>
                 <c:pt idx="3">
+                  <c:v>JORDAN TRUE FLIGHT (MS)</c:v>
+                </c:pt>
+                <c:pt idx="4">
                   <c:v>AIR JORDAN 1 LOW SE (MS/WS)</c:v>
-                </c:pt>
-                <c:pt idx="4">
-                  <c:v>WMNS BENASSI JDI</c:v>
                 </c:pt>
               </c:strCache>
             </c:strRef>
@@ -249,19 +249,19 @@
                 <c:formatCode>0.00%</c:formatCode>
                 <c:ptCount val="5"/>
                 <c:pt idx="0">
-                  <c:v>0.015295</c:v>
+                  <c:v>0.010361</c:v>
                 </c:pt>
                 <c:pt idx="1">
-                  <c:v>0.010361</c:v>
+                  <c:v>0.009336</c:v>
                 </c:pt>
                 <c:pt idx="2">
-                  <c:v>0.009455</c:v>
+                  <c:v>0.007919</c:v>
                 </c:pt>
                 <c:pt idx="3">
-                  <c:v>0.007190</c:v>
+                  <c:v>0.006843</c:v>
                 </c:pt>
                 <c:pt idx="4">
-                  <c:v>0.006136</c:v>
+                  <c:v>0.006665</c:v>
                 </c:pt>
               </c:numCache>
             </c:numRef>
@@ -586,7 +586,7 @@
           <c:order val="0"/>
           <c:tx>
             <c:strRef>
-              <c:f>'Current month'!$M$21</c:f>
+              <c:f>'HFPA'!$M$27</c:f>
               <c:strCache>
                 <c:ptCount val="1"/>
                 <c:pt idx="0">
@@ -639,47 +639,47 @@
           </c:dLbls>
           <c:cat>
             <c:strRef>
-              <c:f>'Current month'!$L$28:$L$32</c:f>
+              <c:f>'HFPA'!$L$28:$L$32</c:f>
               <c:strCache>
                 <c:ptCount val="5"/>
                 <c:pt idx="0">
+                  <c:v>NIKE AIR MAX EXCEE (MS/WS)</c:v>
+                </c:pt>
+                <c:pt idx="1">
                   <c:v>NIKE INITIATOR (MS/WS)</c:v>
                 </c:pt>
-                <c:pt idx="1">
-                  <c:v>NIKE RUN DEFY (MS/WS)</c:v>
-                </c:pt>
                 <c:pt idx="2">
-                  <c:v>NIKE AIR MAX EXCEE (MS/WS)</c:v>
+                  <c:v>NIKE AIR MAX SC (MS/WS)</c:v>
                 </c:pt>
                 <c:pt idx="3">
+                  <c:v>NIKE AIR WINFLO 12 (MS/WS)</c:v>
+                </c:pt>
+                <c:pt idx="4">
                   <c:v>NIKE UPLIFT SC (MS/WS)</c:v>
-                </c:pt>
-                <c:pt idx="4">
-                  <c:v>NIKE AIR MAX SC (MS/WS)</c:v>
                 </c:pt>
               </c:strCache>
             </c:strRef>
           </c:cat>
           <c:val>
             <c:numRef>
-              <c:f>'Current month'!$M$28:$M$32</c:f>
+              <c:f>'HFPA'!$M$28:$M$32</c:f>
               <c:numCache>
                 <c:formatCode>0.00%</c:formatCode>
                 <c:ptCount val="5"/>
                 <c:pt idx="0">
-                  <c:v>0.139047</c:v>
+                  <c:v>0.177203</c:v>
                 </c:pt>
                 <c:pt idx="1">
-                  <c:v>0.143290</c:v>
+                  <c:v>0.134142</c:v>
                 </c:pt>
                 <c:pt idx="2">
-                  <c:v>0.185542</c:v>
+                  <c:v>0.150311</c:v>
                 </c:pt>
                 <c:pt idx="3">
-                  <c:v>0.157343</c:v>
+                  <c:v>0.153706</c:v>
                 </c:pt>
                 <c:pt idx="4">
-                  <c:v>0.120352</c:v>
+                  <c:v>0.135455</c:v>
                 </c:pt>
               </c:numCache>
             </c:numRef>
@@ -690,7 +690,111 @@
           <c:order val="1"/>
           <c:tx>
             <c:strRef>
-              <c:f>'Current month'!$N$21</c:f>
+              <c:f>'HFPA'!$N$27</c:f>
+              <c:strCache>
+                <c:ptCount val="1"/>
+                <c:pt idx="0">
+                  <c:v>Over cement</c:v>
+                </c:pt>
+              </c:strCache>
+            </c:strRef>
+          </c:tx>
+          <c:spPr>
+            <a:solidFill>
+              <a:srgbClr val="4F6228"/>
+            </a:solidFill>
+            <a:ln>
+              <a:noFill/>
+            </a:ln>
+          </c:spPr>
+          <c:invertIfNegative val="0"/>
+          <c:dLbls>
+            <c:spPr>
+              <a:noFill/>
+              <a:ln>
+                <a:noFill/>
+              </a:ln>
+            </c:spPr>
+            <c:txPr>
+              <a:bodyPr rot="0" spcFirstLastPara="1" vertOverflow="ellipsis" vert="horz" wrap="square" lIns="19050" tIns="9525" rIns="19050" bIns="9525" anchor="ctr" anchorCtr="1">
+                <a:spAutoFit/>
+              </a:bodyPr>
+              <a:lstStyle/>
+              <a:p>
+                <a:pPr>
+                  <a:defRPr lang="en-US" sz="700" b="1" i="0" baseline="0">
+                    <a:solidFill>
+                      <a:srgbClr val="FFFFFF"/>
+                    </a:solidFill>
+                    <a:latin typeface="Calibri"/>
+                  </a:defRPr>
+                </a:pPr>
+              </a:p>
+            </c:txPr>
+            <c:numFmt formatCode="0.00%" sourceLinked="0"/>
+            <c:dLblPos val="ctr"/>
+            <c:showLegendKey val="0"/>
+            <c:showVal val="1"/>
+            <c:showCatName val="0"/>
+            <c:showSerName val="0"/>
+            <c:showPercent val="0"/>
+            <c:showBubbleSize val="0"/>
+            <c:showLeaderLines val="0"/>
+          </c:dLbls>
+          <c:cat>
+            <c:strRef>
+              <c:f>'HFPA'!$L$28:$L$32</c:f>
+              <c:strCache>
+                <c:ptCount val="5"/>
+                <c:pt idx="0">
+                  <c:v>NIKE AIR MAX EXCEE (MS/WS)</c:v>
+                </c:pt>
+                <c:pt idx="1">
+                  <c:v>NIKE INITIATOR (MS/WS)</c:v>
+                </c:pt>
+                <c:pt idx="2">
+                  <c:v>NIKE AIR MAX SC (MS/WS)</c:v>
+                </c:pt>
+                <c:pt idx="3">
+                  <c:v>NIKE AIR WINFLO 12 (MS/WS)</c:v>
+                </c:pt>
+                <c:pt idx="4">
+                  <c:v>NIKE UPLIFT SC (MS/WS)</c:v>
+                </c:pt>
+              </c:strCache>
+            </c:strRef>
+          </c:cat>
+          <c:val>
+            <c:numRef>
+              <c:f>'HFPA'!$N$28:$N$32</c:f>
+              <c:numCache>
+                <c:formatCode>0.00%</c:formatCode>
+                <c:ptCount val="5"/>
+                <c:pt idx="0">
+                  <c:v>0.104737</c:v>
+                </c:pt>
+                <c:pt idx="1">
+                  <c:v>0.115120</c:v>
+                </c:pt>
+                <c:pt idx="2">
+                  <c:v>0.118012</c:v>
+                </c:pt>
+                <c:pt idx="3">
+                  <c:v>0.114598</c:v>
+                </c:pt>
+                <c:pt idx="4">
+                  <c:v>0.116818</c:v>
+                </c:pt>
+              </c:numCache>
+            </c:numRef>
+          </c:val>
+        </c:ser>
+        <c:ser>
+          <c:idx val="2"/>
+          <c:order val="2"/>
+          <c:tx>
+            <c:strRef>
+              <c:f>'HFPA'!$O$27</c:f>
               <c:strCache>
                 <c:ptCount val="1"/>
                 <c:pt idx="0">
@@ -743,145 +847,44 @@
           </c:dLbls>
           <c:cat>
             <c:strRef>
-              <c:f>'Current month'!$L$28:$L$32</c:f>
+              <c:f>'HFPA'!$L$28:$L$32</c:f>
               <c:strCache>
                 <c:ptCount val="5"/>
                 <c:pt idx="0">
+                  <c:v>NIKE AIR MAX EXCEE (MS/WS)</c:v>
+                </c:pt>
+                <c:pt idx="1">
                   <c:v>NIKE INITIATOR (MS/WS)</c:v>
                 </c:pt>
-                <c:pt idx="1">
-                  <c:v>NIKE RUN DEFY (MS/WS)</c:v>
-                </c:pt>
                 <c:pt idx="2">
-                  <c:v>NIKE AIR MAX EXCEE (MS/WS)</c:v>
+                  <c:v>NIKE AIR MAX SC (MS/WS)</c:v>
                 </c:pt>
                 <c:pt idx="3">
+                  <c:v>NIKE AIR WINFLO 12 (MS/WS)</c:v>
+                </c:pt>
+                <c:pt idx="4">
                   <c:v>NIKE UPLIFT SC (MS/WS)</c:v>
-                </c:pt>
-                <c:pt idx="4">
-                  <c:v>NIKE AIR MAX SC (MS/WS)</c:v>
                 </c:pt>
               </c:strCache>
             </c:strRef>
           </c:cat>
           <c:val>
             <c:numRef>
-              <c:f>'Current month'!$N$28:$N$32</c:f>
+              <c:f>'HFPA'!$O$28:$O$32</c:f>
               <c:numCache>
                 <c:formatCode>0.00%</c:formatCode>
                 <c:ptCount val="5"/>
                 <c:pt idx="0">
-                  <c:v>0.093271</c:v>
+                  <c:v>0.143612</c:v>
                 </c:pt>
                 <c:pt idx="1">
-                  <c:v>0.117513</c:v>
+                  <c:v>0.094785</c:v>
                 </c:pt>
                 <c:pt idx="2">
-                  <c:v>0.138813</c:v>
+                  <c:v>0.143685</c:v>
                 </c:pt>
                 <c:pt idx="4">
-                  <c:v>0.121028</c:v>
-                </c:pt>
-              </c:numCache>
-            </c:numRef>
-          </c:val>
-        </c:ser>
-        <c:ser>
-          <c:idx val="2"/>
-          <c:order val="2"/>
-          <c:tx>
-            <c:strRef>
-              <c:f>'Current month'!$O$21</c:f>
-              <c:strCache>
-                <c:ptCount val="1"/>
-                <c:pt idx="0">
-                  <c:v>Over cement</c:v>
-                </c:pt>
-              </c:strCache>
-            </c:strRef>
-          </c:tx>
-          <c:spPr>
-            <a:solidFill>
-              <a:srgbClr val="4F6228"/>
-            </a:solidFill>
-            <a:ln>
-              <a:noFill/>
-            </a:ln>
-          </c:spPr>
-          <c:invertIfNegative val="0"/>
-          <c:dLbls>
-            <c:spPr>
-              <a:noFill/>
-              <a:ln>
-                <a:noFill/>
-              </a:ln>
-            </c:spPr>
-            <c:txPr>
-              <a:bodyPr rot="0" spcFirstLastPara="1" vertOverflow="ellipsis" vert="horz" wrap="square" lIns="19050" tIns="9525" rIns="19050" bIns="9525" anchor="ctr" anchorCtr="1">
-                <a:spAutoFit/>
-              </a:bodyPr>
-              <a:lstStyle/>
-              <a:p>
-                <a:pPr>
-                  <a:defRPr lang="en-US" sz="700" b="1" i="0" baseline="0">
-                    <a:solidFill>
-                      <a:srgbClr val="FFFFFF"/>
-                    </a:solidFill>
-                    <a:latin typeface="Calibri"/>
-                  </a:defRPr>
-                </a:pPr>
-              </a:p>
-            </c:txPr>
-            <c:numFmt formatCode="0.00%" sourceLinked="0"/>
-            <c:dLblPos val="ctr"/>
-            <c:showLegendKey val="0"/>
-            <c:showVal val="1"/>
-            <c:showCatName val="0"/>
-            <c:showSerName val="0"/>
-            <c:showPercent val="0"/>
-            <c:showBubbleSize val="0"/>
-            <c:showLeaderLines val="0"/>
-          </c:dLbls>
-          <c:cat>
-            <c:strRef>
-              <c:f>'Current month'!$L$28:$L$32</c:f>
-              <c:strCache>
-                <c:ptCount val="5"/>
-                <c:pt idx="0">
-                  <c:v>NIKE INITIATOR (MS/WS)</c:v>
-                </c:pt>
-                <c:pt idx="1">
-                  <c:v>NIKE RUN DEFY (MS/WS)</c:v>
-                </c:pt>
-                <c:pt idx="2">
-                  <c:v>NIKE AIR MAX EXCEE (MS/WS)</c:v>
-                </c:pt>
-                <c:pt idx="3">
-                  <c:v>NIKE UPLIFT SC (MS/WS)</c:v>
-                </c:pt>
-                <c:pt idx="4">
-                  <c:v>NIKE AIR MAX SC (MS/WS)</c:v>
-                </c:pt>
-              </c:strCache>
-            </c:strRef>
-          </c:cat>
-          <c:val>
-            <c:numRef>
-              <c:f>'Current month'!$O$28:$O$32</c:f>
-              <c:numCache>
-                <c:formatCode>0.00%</c:formatCode>
-                <c:ptCount val="5"/>
-                <c:pt idx="0">
-                  <c:v>0.115815</c:v>
-                </c:pt>
-                <c:pt idx="1">
-                  <c:v>0.112964</c:v>
-                </c:pt>
-                <c:pt idx="2">
-                  <c:v>0.121495</c:v>
-                </c:pt>
-                <c:pt idx="3">
-                  <c:v>0.096737</c:v>
+                  <c:v>0.096818</c:v>
                 </c:pt>
               </c:numCache>
             </c:numRef>
@@ -892,18 +895,18 @@
           <c:order val="3"/>
           <c:tx>
             <c:strRef>
-              <c:f>'Current month'!$P$21</c:f>
+              <c:f>'HFPA'!$P$27</c:f>
               <c:strCache>
                 <c:ptCount val="1"/>
                 <c:pt idx="0">
-                  <c:v>Airbag quality/stain</c:v>
+                  <c:v>Bottom Cosmetic</c:v>
                 </c:pt>
               </c:strCache>
             </c:strRef>
           </c:tx>
           <c:spPr>
             <a:solidFill>
-              <a:srgbClr val="59E4B4"/>
+              <a:srgbClr val="D99694"/>
             </a:solidFill>
             <a:ln>
               <a:noFill/>
@@ -945,127 +948,35 @@
           </c:dLbls>
           <c:cat>
             <c:strRef>
-              <c:f>'Current month'!$L$28:$L$32</c:f>
+              <c:f>'HFPA'!$L$28:$L$32</c:f>
               <c:strCache>
                 <c:ptCount val="5"/>
                 <c:pt idx="0">
+                  <c:v>NIKE AIR MAX EXCEE (MS/WS)</c:v>
+                </c:pt>
+                <c:pt idx="1">
                   <c:v>NIKE INITIATOR (MS/WS)</c:v>
                 </c:pt>
-                <c:pt idx="1">
-                  <c:v>NIKE RUN DEFY (MS/WS)</c:v>
-                </c:pt>
                 <c:pt idx="2">
-                  <c:v>NIKE AIR MAX EXCEE (MS/WS)</c:v>
+                  <c:v>NIKE AIR MAX SC (MS/WS)</c:v>
                 </c:pt>
                 <c:pt idx="3">
+                  <c:v>NIKE AIR WINFLO 12 (MS/WS)</c:v>
+                </c:pt>
+                <c:pt idx="4">
                   <c:v>NIKE UPLIFT SC (MS/WS)</c:v>
-                </c:pt>
-                <c:pt idx="4">
-                  <c:v>NIKE AIR MAX SC (MS/WS)</c:v>
                 </c:pt>
               </c:strCache>
             </c:strRef>
           </c:cat>
           <c:val>
             <c:numRef>
-              <c:f>'Current month'!$P$28:$P$32</c:f>
-              <c:numCache>
-                <c:formatCode>0.00%</c:formatCode>
-                <c:ptCount val="5"/>
-                <c:pt idx="4">
-                  <c:v>0.114943</c:v>
-                </c:pt>
-              </c:numCache>
-            </c:numRef>
-          </c:val>
-        </c:ser>
-        <c:ser>
-          <c:idx val="4"/>
-          <c:order val="4"/>
-          <c:tx>
-            <c:strRef>
-              <c:f>'Current month'!$Q$21</c:f>
-              <c:strCache>
-                <c:ptCount val="1"/>
-                <c:pt idx="0">
-                  <c:v>Midsole/Outsole to upper bond gap</c:v>
-                </c:pt>
-              </c:strCache>
-            </c:strRef>
-          </c:tx>
-          <c:spPr>
-            <a:solidFill>
-              <a:srgbClr val="F79646"/>
-            </a:solidFill>
-            <a:ln>
-              <a:noFill/>
-            </a:ln>
-          </c:spPr>
-          <c:invertIfNegative val="0"/>
-          <c:dLbls>
-            <c:spPr>
-              <a:noFill/>
-              <a:ln>
-                <a:noFill/>
-              </a:ln>
-            </c:spPr>
-            <c:txPr>
-              <a:bodyPr rot="0" spcFirstLastPara="1" vertOverflow="ellipsis" vert="horz" wrap="square" lIns="19050" tIns="9525" rIns="19050" bIns="9525" anchor="ctr" anchorCtr="1">
-                <a:spAutoFit/>
-              </a:bodyPr>
-              <a:lstStyle/>
-              <a:p>
-                <a:pPr>
-                  <a:defRPr lang="en-US" sz="700" b="1" i="0" baseline="0">
-                    <a:solidFill>
-                      <a:srgbClr val="000000"/>
-                    </a:solidFill>
-                    <a:latin typeface="Calibri"/>
-                  </a:defRPr>
-                </a:pPr>
-              </a:p>
-            </c:txPr>
-            <c:numFmt formatCode="0.00%" sourceLinked="0"/>
-            <c:dLblPos val="ctr"/>
-            <c:showLegendKey val="0"/>
-            <c:showVal val="1"/>
-            <c:showCatName val="0"/>
-            <c:showSerName val="0"/>
-            <c:showPercent val="0"/>
-            <c:showBubbleSize val="0"/>
-            <c:showLeaderLines val="0"/>
-          </c:dLbls>
-          <c:cat>
-            <c:strRef>
-              <c:f>'Current month'!$L$28:$L$32</c:f>
-              <c:strCache>
-                <c:ptCount val="5"/>
-                <c:pt idx="0">
-                  <c:v>NIKE INITIATOR (MS/WS)</c:v>
-                </c:pt>
-                <c:pt idx="1">
-                  <c:v>NIKE RUN DEFY (MS/WS)</c:v>
-                </c:pt>
-                <c:pt idx="2">
-                  <c:v>NIKE AIR MAX EXCEE (MS/WS)</c:v>
-                </c:pt>
-                <c:pt idx="3">
-                  <c:v>NIKE UPLIFT SC (MS/WS)</c:v>
-                </c:pt>
-                <c:pt idx="4">
-                  <c:v>NIKE AIR MAX SC (MS/WS)</c:v>
-                </c:pt>
-              </c:strCache>
-            </c:strRef>
-          </c:cat>
-          <c:val>
-            <c:numRef>
-              <c:f>'Current month'!$Q$28:$Q$32</c:f>
+              <c:f>'HFPA'!$P$28:$P$32</c:f>
               <c:numCache>
                 <c:formatCode>0.00%</c:formatCode>
                 <c:ptCount val="5"/>
                 <c:pt idx="3">
-                  <c:v>0.088578</c:v>
+                  <c:v>0.109141</c:v>
                 </c:pt>
               </c:numCache>
             </c:numRef>
@@ -1125,7 +1036,7 @@
                     <a:solidFill>
                       <a:schemeClr val="tx1"/>
                     </a:solidFill>
-                    <a:effectLst/>
+                    <a:latin typeface="+mn-lt"/>
                   </a:rPr>
                   <a:t>First priority: Cleanness</a:t>
                 </a:r>
@@ -1378,7 +1289,111 @@
           <c:order val="0"/>
           <c:tx>
             <c:strRef>
-              <c:f>'Current month'!$M$21</c:f>
+              <c:f>'HFPA'!$M$33</c:f>
+              <c:strCache>
+                <c:ptCount val="1"/>
+                <c:pt idx="0">
+                  <c:v>Over cement</c:v>
+                </c:pt>
+              </c:strCache>
+            </c:strRef>
+          </c:tx>
+          <c:spPr>
+            <a:solidFill>
+              <a:srgbClr val="4F6228"/>
+            </a:solidFill>
+            <a:ln>
+              <a:noFill/>
+            </a:ln>
+          </c:spPr>
+          <c:invertIfNegative val="0"/>
+          <c:dLbls>
+            <c:spPr>
+              <a:noFill/>
+              <a:ln>
+                <a:noFill/>
+              </a:ln>
+            </c:spPr>
+            <c:txPr>
+              <a:bodyPr rot="0" spcFirstLastPara="1" vertOverflow="ellipsis" vert="horz" wrap="square" lIns="19050" tIns="9525" rIns="19050" bIns="9525" anchor="ctr" anchorCtr="1">
+                <a:spAutoFit/>
+              </a:bodyPr>
+              <a:lstStyle/>
+              <a:p>
+                <a:pPr>
+                  <a:defRPr lang="en-US" sz="700" b="1" i="0" baseline="0">
+                    <a:solidFill>
+                      <a:srgbClr val="FFFFFF"/>
+                    </a:solidFill>
+                    <a:latin typeface="Calibri"/>
+                  </a:defRPr>
+                </a:pPr>
+              </a:p>
+            </c:txPr>
+            <c:numFmt formatCode="0.00%" sourceLinked="0"/>
+            <c:dLblPos val="ctr"/>
+            <c:showLegendKey val="0"/>
+            <c:showVal val="1"/>
+            <c:showCatName val="0"/>
+            <c:showSerName val="0"/>
+            <c:showPercent val="0"/>
+            <c:showBubbleSize val="0"/>
+            <c:showLeaderLines val="0"/>
+          </c:dLbls>
+          <c:cat>
+            <c:strRef>
+              <c:f>'HFPA'!$L$34:$L$38</c:f>
+              <c:strCache>
+                <c:ptCount val="5"/>
+                <c:pt idx="0">
+                  <c:v>NIKE INITIATOR (MS/WS)</c:v>
+                </c:pt>
+                <c:pt idx="1">
+                  <c:v>NIKE EBERNON LOW (MS/WS)</c:v>
+                </c:pt>
+                <c:pt idx="2">
+                  <c:v>NIKE AIR MAX MOTION 2 (MS/WS)</c:v>
+                </c:pt>
+                <c:pt idx="3">
+                  <c:v>NIKE STAR RUNNER 5 (PS)</c:v>
+                </c:pt>
+                <c:pt idx="4">
+                  <c:v>NIKE COURT BOROUGH LOW RECRAFT (TD)</c:v>
+                </c:pt>
+              </c:strCache>
+            </c:strRef>
+          </c:cat>
+          <c:val>
+            <c:numRef>
+              <c:f>'HFPA'!$M$34:$M$38</c:f>
+              <c:numCache>
+                <c:formatCode>0.00%</c:formatCode>
+                <c:ptCount val="5"/>
+                <c:pt idx="0">
+                  <c:v>0.167945</c:v>
+                </c:pt>
+                <c:pt idx="1">
+                  <c:v>0.129422</c:v>
+                </c:pt>
+                <c:pt idx="2">
+                  <c:v>0.151807</c:v>
+                </c:pt>
+                <c:pt idx="3">
+                  <c:v>0.114206</c:v>
+                </c:pt>
+                <c:pt idx="4">
+                  <c:v>0.342723</c:v>
+                </c:pt>
+              </c:numCache>
+            </c:numRef>
+          </c:val>
+        </c:ser>
+        <c:ser>
+          <c:idx val="1"/>
+          <c:order val="1"/>
+          <c:tx>
+            <c:strRef>
+              <c:f>'HFPA'!$N$33</c:f>
               <c:strCache>
                 <c:ptCount val="1"/>
                 <c:pt idx="0">
@@ -1431,7 +1446,7 @@
           </c:dLbls>
           <c:cat>
             <c:strRef>
-              <c:f>'Current month'!$L$34:$L$38</c:f>
+              <c:f>'HFPA'!$L$34:$L$38</c:f>
               <c:strCache>
                 <c:ptCount val="5"/>
                 <c:pt idx="0">
@@ -1441,141 +1456,34 @@
                   <c:v>NIKE EBERNON LOW (MS/WS)</c:v>
                 </c:pt>
                 <c:pt idx="2">
-                  <c:v>NIKE AIR MAX SC (MS/WS)</c:v>
+                  <c:v>NIKE AIR MAX MOTION 2 (MS/WS)</c:v>
                 </c:pt>
                 <c:pt idx="3">
-                  <c:v>NIKE COURT VISION LOW (MS/WS)</c:v>
+                  <c:v>NIKE STAR RUNNER 5 (PS)</c:v>
                 </c:pt>
                 <c:pt idx="4">
-                  <c:v>NIKE AIR MAX MOTION 2 (MS/WS)</c:v>
+                  <c:v>NIKE COURT BOROUGH LOW RECRAFT (TD)</c:v>
                 </c:pt>
               </c:strCache>
             </c:strRef>
           </c:cat>
           <c:val>
             <c:numRef>
-              <c:f>'Current month'!$M$34:$M$38</c:f>
+              <c:f>'HFPA'!$N$34:$N$38</c:f>
               <c:numCache>
                 <c:formatCode>0.00%</c:formatCode>
                 <c:ptCount val="5"/>
                 <c:pt idx="0">
-                  <c:v>0.107877</c:v>
+                  <c:v>0.150365</c:v>
                 </c:pt>
                 <c:pt idx="1">
-                  <c:v>0.166272</c:v>
-                </c:pt>
-                <c:pt idx="2">
-                  <c:v>0.198728</c:v>
+                  <c:v>0.152310</c:v>
                 </c:pt>
                 <c:pt idx="3">
-                  <c:v>0.126961</c:v>
+                  <c:v>0.175487</c:v>
                 </c:pt>
                 <c:pt idx="4">
-                  <c:v>0.135179</c:v>
-                </c:pt>
-              </c:numCache>
-            </c:numRef>
-          </c:val>
-        </c:ser>
-        <c:ser>
-          <c:idx val="1"/>
-          <c:order val="1"/>
-          <c:tx>
-            <c:strRef>
-              <c:f>'Current month'!$N$21</c:f>
-              <c:strCache>
-                <c:ptCount val="1"/>
-                <c:pt idx="0">
-                  <c:v>Over cement</c:v>
-                </c:pt>
-              </c:strCache>
-            </c:strRef>
-          </c:tx>
-          <c:spPr>
-            <a:solidFill>
-              <a:srgbClr val="4F6228"/>
-            </a:solidFill>
-            <a:ln>
-              <a:noFill/>
-            </a:ln>
-          </c:spPr>
-          <c:invertIfNegative val="0"/>
-          <c:dLbls>
-            <c:spPr>
-              <a:noFill/>
-              <a:ln>
-                <a:noFill/>
-              </a:ln>
-            </c:spPr>
-            <c:txPr>
-              <a:bodyPr rot="0" spcFirstLastPara="1" vertOverflow="ellipsis" vert="horz" wrap="square" lIns="19050" tIns="9525" rIns="19050" bIns="9525" anchor="ctr" anchorCtr="1">
-                <a:spAutoFit/>
-              </a:bodyPr>
-              <a:lstStyle/>
-              <a:p>
-                <a:pPr>
-                  <a:defRPr lang="en-US" sz="700" b="1" i="0" baseline="0">
-                    <a:solidFill>
-                      <a:srgbClr val="FFFFFF"/>
-                    </a:solidFill>
-                    <a:latin typeface="Calibri"/>
-                  </a:defRPr>
-                </a:pPr>
-              </a:p>
-            </c:txPr>
-            <c:numFmt formatCode="0.00%" sourceLinked="0"/>
-            <c:dLblPos val="ctr"/>
-            <c:showLegendKey val="0"/>
-            <c:showVal val="1"/>
-            <c:showCatName val="0"/>
-            <c:showSerName val="0"/>
-            <c:showPercent val="0"/>
-            <c:showBubbleSize val="0"/>
-            <c:showLeaderLines val="0"/>
-          </c:dLbls>
-          <c:cat>
-            <c:strRef>
-              <c:f>'Current month'!$L$34:$L$38</c:f>
-              <c:strCache>
-                <c:ptCount val="5"/>
-                <c:pt idx="0">
-                  <c:v>NIKE INITIATOR (MS/WS)</c:v>
-                </c:pt>
-                <c:pt idx="1">
-                  <c:v>NIKE EBERNON LOW (MS/WS)</c:v>
-                </c:pt>
-                <c:pt idx="2">
-                  <c:v>NIKE AIR MAX SC (MS/WS)</c:v>
-                </c:pt>
-                <c:pt idx="3">
-                  <c:v>NIKE COURT VISION LOW (MS/WS)</c:v>
-                </c:pt>
-                <c:pt idx="4">
-                  <c:v>NIKE AIR MAX MOTION 2 (MS/WS)</c:v>
-                </c:pt>
-              </c:strCache>
-            </c:strRef>
-          </c:cat>
-          <c:val>
-            <c:numRef>
-              <c:f>'Current month'!$N$34:$N$38</c:f>
-              <c:numCache>
-                <c:formatCode>0.00%</c:formatCode>
-                <c:ptCount val="5"/>
-                <c:pt idx="0">
-                  <c:v>0.162329</c:v>
-                </c:pt>
-                <c:pt idx="1">
-                  <c:v>0.135007</c:v>
-                </c:pt>
-                <c:pt idx="2">
-                  <c:v>0.163752</c:v>
-                </c:pt>
-                <c:pt idx="3">
-                  <c:v>0.111270</c:v>
-                </c:pt>
-                <c:pt idx="4">
-                  <c:v>0.135179</c:v>
+                  <c:v>0.258216</c:v>
                 </c:pt>
               </c:numCache>
             </c:numRef>
@@ -1586,7 +1494,7 @@
           <c:order val="2"/>
           <c:tx>
             <c:strRef>
-              <c:f>'Current month'!$O$21</c:f>
+              <c:f>'HFPA'!$O$33</c:f>
               <c:strCache>
                 <c:ptCount val="1"/>
                 <c:pt idx="0">
@@ -1639,7 +1547,7 @@
           </c:dLbls>
           <c:cat>
             <c:strRef>
-              <c:f>'Current month'!$L$34:$L$38</c:f>
+              <c:f>'HFPA'!$L$34:$L$38</c:f>
               <c:strCache>
                 <c:ptCount val="5"/>
                 <c:pt idx="0">
@@ -1649,34 +1557,37 @@
                   <c:v>NIKE EBERNON LOW (MS/WS)</c:v>
                 </c:pt>
                 <c:pt idx="2">
-                  <c:v>NIKE AIR MAX SC (MS/WS)</c:v>
+                  <c:v>NIKE AIR MAX MOTION 2 (MS/WS)</c:v>
                 </c:pt>
                 <c:pt idx="3">
-                  <c:v>NIKE COURT VISION LOW (MS/WS)</c:v>
+                  <c:v>NIKE STAR RUNNER 5 (PS)</c:v>
                 </c:pt>
                 <c:pt idx="4">
-                  <c:v>NIKE AIR MAX MOTION 2 (MS/WS)</c:v>
+                  <c:v>NIKE COURT BOROUGH LOW RECRAFT (TD)</c:v>
                 </c:pt>
               </c:strCache>
             </c:strRef>
           </c:cat>
           <c:val>
             <c:numRef>
-              <c:f>'Current month'!$O$34:$O$38</c:f>
+              <c:f>'HFPA'!$O$34:$O$38</c:f>
               <c:numCache>
                 <c:formatCode>0.00%</c:formatCode>
                 <c:ptCount val="5"/>
                 <c:pt idx="0">
-                  <c:v>0.114726</c:v>
+                  <c:v>0.100991</c:v>
                 </c:pt>
                 <c:pt idx="1">
-                  <c:v>0.092847</c:v>
+                  <c:v>0.108198</c:v>
+                </c:pt>
+                <c:pt idx="2">
+                  <c:v>0.120482</c:v>
                 </c:pt>
                 <c:pt idx="3">
-                  <c:v>0.108417</c:v>
+                  <c:v>0.112813</c:v>
                 </c:pt>
                 <c:pt idx="4">
-                  <c:v>0.153094</c:v>
+                  <c:v>0.097027</c:v>
                 </c:pt>
               </c:numCache>
             </c:numRef>
@@ -1687,18 +1598,18 @@
           <c:order val="3"/>
           <c:tx>
             <c:strRef>
-              <c:f>'Current month'!$P$21</c:f>
+              <c:f>'HFPA'!$P$33</c:f>
               <c:strCache>
                 <c:ptCount val="1"/>
                 <c:pt idx="0">
-                  <c:v>Sole attachment</c:v>
+                  <c:v>Bottom Cosmetic</c:v>
                 </c:pt>
               </c:strCache>
             </c:strRef>
           </c:tx>
           <c:spPr>
             <a:solidFill>
-              <a:srgbClr val="C3D4EF"/>
+              <a:srgbClr val="D99694"/>
             </a:solidFill>
             <a:ln>
               <a:noFill/>
@@ -1740,7 +1651,7 @@
           </c:dLbls>
           <c:cat>
             <c:strRef>
-              <c:f>'Current month'!$L$34:$L$38</c:f>
+              <c:f>'HFPA'!$L$34:$L$38</c:f>
               <c:strCache>
                 <c:ptCount val="5"/>
                 <c:pt idx="0">
@@ -1750,25 +1661,25 @@
                   <c:v>NIKE EBERNON LOW (MS/WS)</c:v>
                 </c:pt>
                 <c:pt idx="2">
-                  <c:v>NIKE AIR MAX SC (MS/WS)</c:v>
+                  <c:v>NIKE AIR MAX MOTION 2 (MS/WS)</c:v>
                 </c:pt>
                 <c:pt idx="3">
-                  <c:v>NIKE COURT VISION LOW (MS/WS)</c:v>
+                  <c:v>NIKE STAR RUNNER 5 (PS)</c:v>
                 </c:pt>
                 <c:pt idx="4">
-                  <c:v>NIKE AIR MAX MOTION 2 (MS/WS)</c:v>
+                  <c:v>NIKE COURT BOROUGH LOW RECRAFT (TD)</c:v>
                 </c:pt>
               </c:strCache>
             </c:strRef>
           </c:cat>
           <c:val>
             <c:numRef>
-              <c:f>'Current month'!$P$34:$P$38</c:f>
+              <c:f>'HFPA'!$P$34:$P$38</c:f>
               <c:numCache>
                 <c:formatCode>0.00%</c:formatCode>
                 <c:ptCount val="5"/>
                 <c:pt idx="2">
-                  <c:v>0.082671</c:v>
+                  <c:v>0.135743</c:v>
                 </c:pt>
               </c:numCache>
             </c:numRef>
@@ -1825,9 +1736,12 @@
                 </a:pPr>
                 <a:r>
                   <a:rPr lang="en-US" sz="800" b="0" i="0" u="sng" baseline="0">
-                    <a:effectLst/>
+                    <a:solidFill>
+                      <a:schemeClr val="tx1"/>
+                    </a:solidFill>
+                    <a:latin typeface="+mn-lt"/>
                   </a:rPr>
-                  <a:t>First priority: Cleanness</a:t>
+                  <a:t>First priority: Over cement</a:t>
                 </a:r>
                 <a:endParaRPr lang="vi-VN" sz="800">
                   <a:effectLst/>
@@ -2082,7 +1996,111 @@
           <c:order val="0"/>
           <c:tx>
             <c:strRef>
-              <c:f>'Current month'!$M$21</c:f>
+              <c:f>'HFPA'!$M$39</c:f>
+              <c:strCache>
+                <c:ptCount val="1"/>
+                <c:pt idx="0">
+                  <c:v>Over cement</c:v>
+                </c:pt>
+              </c:strCache>
+            </c:strRef>
+          </c:tx>
+          <c:spPr>
+            <a:solidFill>
+              <a:srgbClr val="4F6228"/>
+            </a:solidFill>
+            <a:ln>
+              <a:noFill/>
+            </a:ln>
+          </c:spPr>
+          <c:invertIfNegative val="0"/>
+          <c:dLbls>
+            <c:spPr>
+              <a:noFill/>
+              <a:ln>
+                <a:noFill/>
+              </a:ln>
+            </c:spPr>
+            <c:txPr>
+              <a:bodyPr rot="0" spcFirstLastPara="1" vertOverflow="ellipsis" vert="horz" wrap="square" lIns="19050" tIns="9525" rIns="19050" bIns="9525" anchor="ctr" anchorCtr="1">
+                <a:spAutoFit/>
+              </a:bodyPr>
+              <a:lstStyle/>
+              <a:p>
+                <a:pPr>
+                  <a:defRPr lang="en-US" sz="700" b="1" i="0" baseline="0">
+                    <a:solidFill>
+                      <a:srgbClr val="FFFFFF"/>
+                    </a:solidFill>
+                    <a:latin typeface="Calibri"/>
+                  </a:defRPr>
+                </a:pPr>
+              </a:p>
+            </c:txPr>
+            <c:numFmt formatCode="0.00%" sourceLinked="0"/>
+            <c:dLblPos val="ctr"/>
+            <c:showLegendKey val="0"/>
+            <c:showVal val="1"/>
+            <c:showCatName val="0"/>
+            <c:showSerName val="0"/>
+            <c:showPercent val="0"/>
+            <c:showBubbleSize val="0"/>
+            <c:showLeaderLines val="0"/>
+          </c:dLbls>
+          <c:cat>
+            <c:strRef>
+              <c:f>'HFPA'!$L$40:$L$44</c:f>
+              <c:strCache>
+                <c:ptCount val="5"/>
+                <c:pt idx="0">
+                  <c:v>NIKE COURT VISION LOW (MS/WS)</c:v>
+                </c:pt>
+                <c:pt idx="1">
+                  <c:v>NIKE INITIATOR (MS/WS)</c:v>
+                </c:pt>
+                <c:pt idx="2">
+                  <c:v>JORDAN 1 MID SE (PS/TD)</c:v>
+                </c:pt>
+                <c:pt idx="3">
+                  <c:v>AIR JORDAN 1 LOW (MS/WS)</c:v>
+                </c:pt>
+                <c:pt idx="4">
+                  <c:v>AIR JORDAN 1 LOW SE (GS)</c:v>
+                </c:pt>
+              </c:strCache>
+            </c:strRef>
+          </c:cat>
+          <c:val>
+            <c:numRef>
+              <c:f>'HFPA'!$M$40:$M$44</c:f>
+              <c:numCache>
+                <c:formatCode>0.00%</c:formatCode>
+                <c:ptCount val="5"/>
+                <c:pt idx="0">
+                  <c:v>0.160398</c:v>
+                </c:pt>
+                <c:pt idx="1">
+                  <c:v>0.091716</c:v>
+                </c:pt>
+                <c:pt idx="2">
+                  <c:v>0.168724</c:v>
+                </c:pt>
+                <c:pt idx="3">
+                  <c:v>0.205069</c:v>
+                </c:pt>
+                <c:pt idx="4">
+                  <c:v>0.185759</c:v>
+                </c:pt>
+              </c:numCache>
+            </c:numRef>
+          </c:val>
+        </c:ser>
+        <c:ser>
+          <c:idx val="1"/>
+          <c:order val="1"/>
+          <c:tx>
+            <c:strRef>
+              <c:f>'HFPA'!$N$39</c:f>
               <c:strCache>
                 <c:ptCount val="1"/>
                 <c:pt idx="0">
@@ -2135,69 +2153,69 @@
           </c:dLbls>
           <c:cat>
             <c:strRef>
-              <c:f>'Current month'!$L$40:$L$44</c:f>
+              <c:f>'HFPA'!$L$40:$L$44</c:f>
               <c:strCache>
                 <c:ptCount val="5"/>
                 <c:pt idx="0">
                   <c:v>NIKE COURT VISION LOW (MS/WS)</c:v>
                 </c:pt>
                 <c:pt idx="1">
-                  <c:v>AIR JORDAN 1 MID SE (GS)</c:v>
+                  <c:v>NIKE INITIATOR (MS/WS)</c:v>
                 </c:pt>
                 <c:pt idx="2">
                   <c:v>JORDAN 1 MID SE (PS/TD)</c:v>
                 </c:pt>
                 <c:pt idx="3">
-                  <c:v>NIKE INITIATOR (MS/WS)</c:v>
+                  <c:v>AIR JORDAN 1 LOW (MS/WS)</c:v>
                 </c:pt>
                 <c:pt idx="4">
-                  <c:v>AIR JORDAN 1 LOW (MS/WS)</c:v>
+                  <c:v>AIR JORDAN 1 LOW SE (GS)</c:v>
                 </c:pt>
               </c:strCache>
             </c:strRef>
           </c:cat>
           <c:val>
             <c:numRef>
-              <c:f>'Current month'!$M$40:$M$44</c:f>
+              <c:f>'HFPA'!$N$40:$N$44</c:f>
               <c:numCache>
                 <c:formatCode>0.00%</c:formatCode>
                 <c:ptCount val="5"/>
                 <c:pt idx="0">
-                  <c:v>0.145022</c:v>
+                  <c:v>0.141593</c:v>
                 </c:pt>
                 <c:pt idx="1">
-                  <c:v>0.249600</c:v>
+                  <c:v>0.115385</c:v>
                 </c:pt>
                 <c:pt idx="2">
-                  <c:v>0.144737</c:v>
+                  <c:v>0.137860</c:v>
                 </c:pt>
                 <c:pt idx="3">
-                  <c:v>0.117229</c:v>
+                  <c:v>0.170507</c:v>
                 </c:pt>
                 <c:pt idx="4">
-                  <c:v>0.153565</c:v>
+                  <c:v>0.195046</c:v>
                 </c:pt>
               </c:numCache>
             </c:numRef>
           </c:val>
         </c:ser>
         <c:ser>
-          <c:idx val="1"/>
-          <c:order val="1"/>
+          <c:idx val="2"/>
+          <c:order val="2"/>
           <c:tx>
             <c:strRef>
-              <c:f>'Current month'!$N$21</c:f>
+              <c:f>'HFPA'!$O$39</c:f>
               <c:strCache>
                 <c:ptCount val="1"/>
                 <c:pt idx="0">
-                  <c:v>Over cement</c:v>
+                  <c:v>Midsole/Outsole to upper bond gap</c:v>
                 </c:pt>
               </c:strCache>
             </c:strRef>
           </c:tx>
           <c:spPr>
             <a:solidFill>
-              <a:srgbClr val="4F6228"/>
+              <a:srgbClr val="F79646"/>
             </a:solidFill>
             <a:ln>
               <a:noFill/>
@@ -2220,7 +2238,7 @@
                 <a:pPr>
                   <a:defRPr lang="en-US" sz="700" b="1" i="0" baseline="0">
                     <a:solidFill>
-                      <a:srgbClr val="FFFFFF"/>
+                      <a:srgbClr val="000000"/>
                     </a:solidFill>
                     <a:latin typeface="Calibri"/>
                   </a:defRPr>
@@ -2239,58 +2257,49 @@
           </c:dLbls>
           <c:cat>
             <c:strRef>
-              <c:f>'Current month'!$L$40:$L$44</c:f>
+              <c:f>'HFPA'!$L$40:$L$44</c:f>
               <c:strCache>
                 <c:ptCount val="5"/>
                 <c:pt idx="0">
                   <c:v>NIKE COURT VISION LOW (MS/WS)</c:v>
                 </c:pt>
                 <c:pt idx="1">
-                  <c:v>AIR JORDAN 1 MID SE (GS)</c:v>
+                  <c:v>NIKE INITIATOR (MS/WS)</c:v>
                 </c:pt>
                 <c:pt idx="2">
                   <c:v>JORDAN 1 MID SE (PS/TD)</c:v>
                 </c:pt>
                 <c:pt idx="3">
-                  <c:v>NIKE INITIATOR (MS/WS)</c:v>
+                  <c:v>AIR JORDAN 1 LOW (MS/WS)</c:v>
                 </c:pt>
                 <c:pt idx="4">
-                  <c:v>AIR JORDAN 1 LOW (MS/WS)</c:v>
+                  <c:v>AIR JORDAN 1 LOW SE (GS)</c:v>
                 </c:pt>
               </c:strCache>
             </c:strRef>
           </c:cat>
           <c:val>
             <c:numRef>
-              <c:f>'Current month'!$N$40:$N$44</c:f>
+              <c:f>'HFPA'!$O$40:$O$44</c:f>
               <c:numCache>
                 <c:formatCode>0.00%</c:formatCode>
                 <c:ptCount val="5"/>
-                <c:pt idx="0">
-                  <c:v>0.182900</c:v>
-                </c:pt>
-                <c:pt idx="1">
-                  <c:v>0.113600</c:v>
-                </c:pt>
-                <c:pt idx="2">
-                  <c:v>0.184211</c:v>
-                </c:pt>
                 <c:pt idx="3">
-                  <c:v>0.111901</c:v>
+                  <c:v>0.085253</c:v>
                 </c:pt>
                 <c:pt idx="4">
-                  <c:v>0.159049</c:v>
+                  <c:v>0.117647</c:v>
                 </c:pt>
               </c:numCache>
             </c:numRef>
           </c:val>
         </c:ser>
         <c:ser>
-          <c:idx val="2"/>
-          <c:order val="2"/>
+          <c:idx val="3"/>
+          <c:order val="3"/>
           <c:tx>
             <c:strRef>
-              <c:f>'Current month'!$O$21</c:f>
+              <c:f>'HFPA'!$P$39</c:f>
               <c:strCache>
                 <c:ptCount val="1"/>
                 <c:pt idx="0">
@@ -2343,49 +2352,46 @@
           </c:dLbls>
           <c:cat>
             <c:strRef>
-              <c:f>'Current month'!$L$40:$L$44</c:f>
+              <c:f>'HFPA'!$L$40:$L$44</c:f>
               <c:strCache>
                 <c:ptCount val="5"/>
                 <c:pt idx="0">
                   <c:v>NIKE COURT VISION LOW (MS/WS)</c:v>
                 </c:pt>
                 <c:pt idx="1">
-                  <c:v>AIR JORDAN 1 MID SE (GS)</c:v>
+                  <c:v>NIKE INITIATOR (MS/WS)</c:v>
                 </c:pt>
                 <c:pt idx="2">
                   <c:v>JORDAN 1 MID SE (PS/TD)</c:v>
                 </c:pt>
                 <c:pt idx="3">
-                  <c:v>NIKE INITIATOR (MS/WS)</c:v>
+                  <c:v>AIR JORDAN 1 LOW (MS/WS)</c:v>
                 </c:pt>
                 <c:pt idx="4">
-                  <c:v>AIR JORDAN 1 LOW (MS/WS)</c:v>
+                  <c:v>AIR JORDAN 1 LOW SE (GS)</c:v>
                 </c:pt>
               </c:strCache>
             </c:strRef>
           </c:cat>
           <c:val>
             <c:numRef>
-              <c:f>'Current month'!$O$40:$O$44</c:f>
+              <c:f>'HFPA'!$P$40:$P$44</c:f>
               <c:numCache>
                 <c:formatCode>0.00%</c:formatCode>
                 <c:ptCount val="5"/>
-                <c:pt idx="0">
-                  <c:v>0.102814</c:v>
-                </c:pt>
-                <c:pt idx="2">
-                  <c:v>0.086257</c:v>
+                <c:pt idx="1">
+                  <c:v>0.112426</c:v>
                 </c:pt>
               </c:numCache>
             </c:numRef>
           </c:val>
         </c:ser>
         <c:ser>
-          <c:idx val="3"/>
-          <c:order val="3"/>
+          <c:idx val="4"/>
+          <c:order val="4"/>
           <c:tx>
             <c:strRef>
-              <c:f>'Current month'!$P$21</c:f>
+              <c:f>'HFPA'!$Q$39</c:f>
               <c:strCache>
                 <c:ptCount val="1"/>
                 <c:pt idx="0">
@@ -2438,57 +2444,57 @@
           </c:dLbls>
           <c:cat>
             <c:strRef>
-              <c:f>'Current month'!$L$40:$L$44</c:f>
+              <c:f>'HFPA'!$L$40:$L$44</c:f>
               <c:strCache>
                 <c:ptCount val="5"/>
                 <c:pt idx="0">
                   <c:v>NIKE COURT VISION LOW (MS/WS)</c:v>
                 </c:pt>
                 <c:pt idx="1">
-                  <c:v>AIR JORDAN 1 MID SE (GS)</c:v>
+                  <c:v>NIKE INITIATOR (MS/WS)</c:v>
                 </c:pt>
                 <c:pt idx="2">
                   <c:v>JORDAN 1 MID SE (PS/TD)</c:v>
                 </c:pt>
                 <c:pt idx="3">
-                  <c:v>NIKE INITIATOR (MS/WS)</c:v>
+                  <c:v>AIR JORDAN 1 LOW (MS/WS)</c:v>
                 </c:pt>
                 <c:pt idx="4">
-                  <c:v>AIR JORDAN 1 LOW (MS/WS)</c:v>
+                  <c:v>AIR JORDAN 1 LOW SE (GS)</c:v>
                 </c:pt>
               </c:strCache>
             </c:strRef>
           </c:cat>
           <c:val>
             <c:numRef>
-              <c:f>'Current month'!$P$40:$P$44</c:f>
+              <c:f>'HFPA'!$Q$40:$Q$44</c:f>
               <c:numCache>
                 <c:formatCode>0.00%</c:formatCode>
                 <c:ptCount val="5"/>
-                <c:pt idx="3">
-                  <c:v>0.094139</c:v>
+                <c:pt idx="0">
+                  <c:v>0.105088</c:v>
                 </c:pt>
               </c:numCache>
             </c:numRef>
           </c:val>
         </c:ser>
         <c:ser>
-          <c:idx val="4"/>
-          <c:order val="4"/>
+          <c:idx val="5"/>
+          <c:order val="5"/>
           <c:tx>
             <c:strRef>
-              <c:f>'Current month'!$Q$21</c:f>
+              <c:f>'HFPA'!$R$39</c:f>
               <c:strCache>
                 <c:ptCount val="1"/>
                 <c:pt idx="0">
-                  <c:v>Heel/Tip height inconsistent</c:v>
+                  <c:v>Over buffing</c:v>
                 </c:pt>
               </c:strCache>
             </c:strRef>
           </c:tx>
           <c:spPr>
             <a:solidFill>
-              <a:srgbClr val="336A4E"/>
+              <a:srgbClr val="953735"/>
             </a:solidFill>
             <a:ln>
               <a:noFill/>
@@ -2530,127 +2536,35 @@
           </c:dLbls>
           <c:cat>
             <c:strRef>
-              <c:f>'Current month'!$L$40:$L$44</c:f>
+              <c:f>'HFPA'!$L$40:$L$44</c:f>
               <c:strCache>
                 <c:ptCount val="5"/>
                 <c:pt idx="0">
                   <c:v>NIKE COURT VISION LOW (MS/WS)</c:v>
                 </c:pt>
                 <c:pt idx="1">
-                  <c:v>AIR JORDAN 1 MID SE (GS)</c:v>
+                  <c:v>NIKE INITIATOR (MS/WS)</c:v>
                 </c:pt>
                 <c:pt idx="2">
                   <c:v>JORDAN 1 MID SE (PS/TD)</c:v>
                 </c:pt>
                 <c:pt idx="3">
-                  <c:v>NIKE INITIATOR (MS/WS)</c:v>
+                  <c:v>AIR JORDAN 1 LOW (MS/WS)</c:v>
                 </c:pt>
                 <c:pt idx="4">
-                  <c:v>AIR JORDAN 1 LOW (MS/WS)</c:v>
+                  <c:v>AIR JORDAN 1 LOW SE (GS)</c:v>
                 </c:pt>
               </c:strCache>
             </c:strRef>
           </c:cat>
           <c:val>
             <c:numRef>
-              <c:f>'Current month'!$Q$40:$Q$44</c:f>
+              <c:f>'HFPA'!$R$40:$R$44</c:f>
               <c:numCache>
                 <c:formatCode>0.00%</c:formatCode>
                 <c:ptCount val="5"/>
-                <c:pt idx="1">
-                  <c:v>0.091200</c:v>
-                </c:pt>
-              </c:numCache>
-            </c:numRef>
-          </c:val>
-        </c:ser>
-        <c:ser>
-          <c:idx val="5"/>
-          <c:order val="5"/>
-          <c:tx>
-            <c:strRef>
-              <c:f>'Current month'!$R$21</c:f>
-              <c:strCache>
-                <c:ptCount val="1"/>
-                <c:pt idx="0">
-                  <c:v>Rocking</c:v>
-                </c:pt>
-              </c:strCache>
-            </c:strRef>
-          </c:tx>
-          <c:spPr>
-            <a:solidFill>
-              <a:srgbClr val="EAD700"/>
-            </a:solidFill>
-            <a:ln>
-              <a:noFill/>
-            </a:ln>
-          </c:spPr>
-          <c:invertIfNegative val="0"/>
-          <c:dLbls>
-            <c:spPr>
-              <a:noFill/>
-              <a:ln>
-                <a:noFill/>
-              </a:ln>
-            </c:spPr>
-            <c:txPr>
-              <a:bodyPr rot="0" spcFirstLastPara="1" vertOverflow="ellipsis" vert="horz" wrap="square" lIns="19050" tIns="9525" rIns="19050" bIns="9525" anchor="ctr" anchorCtr="1">
-                <a:spAutoFit/>
-              </a:bodyPr>
-              <a:lstStyle/>
-              <a:p>
-                <a:pPr>
-                  <a:defRPr lang="en-US" sz="700" b="1" i="0" baseline="0">
-                    <a:solidFill>
-                      <a:srgbClr val="000000"/>
-                    </a:solidFill>
-                    <a:latin typeface="Calibri"/>
-                  </a:defRPr>
-                </a:pPr>
-              </a:p>
-            </c:txPr>
-            <c:numFmt formatCode="0.00%" sourceLinked="0"/>
-            <c:dLblPos val="ctr"/>
-            <c:showLegendKey val="0"/>
-            <c:showVal val="1"/>
-            <c:showCatName val="0"/>
-            <c:showSerName val="0"/>
-            <c:showPercent val="0"/>
-            <c:showBubbleSize val="0"/>
-            <c:showLeaderLines val="0"/>
-          </c:dLbls>
-          <c:cat>
-            <c:strRef>
-              <c:f>'Current month'!$L$40:$L$44</c:f>
-              <c:strCache>
-                <c:ptCount val="5"/>
-                <c:pt idx="0">
-                  <c:v>NIKE COURT VISION LOW (MS/WS)</c:v>
-                </c:pt>
-                <c:pt idx="1">
-                  <c:v>AIR JORDAN 1 MID SE (GS)</c:v>
-                </c:pt>
                 <c:pt idx="2">
-                  <c:v>JORDAN 1 MID SE (PS/TD)</c:v>
-                </c:pt>
-                <c:pt idx="3">
-                  <c:v>NIKE INITIATOR (MS/WS)</c:v>
-                </c:pt>
-                <c:pt idx="4">
-                  <c:v>AIR JORDAN 1 LOW (MS/WS)</c:v>
-                </c:pt>
-              </c:strCache>
-            </c:strRef>
-          </c:cat>
-          <c:val>
-            <c:numRef>
-              <c:f>'Current month'!$R$40:$R$44</c:f>
-              <c:numCache>
-                <c:formatCode>0.00%</c:formatCode>
-                <c:ptCount val="5"/>
-                <c:pt idx="4">
-                  <c:v>0.084095</c:v>
+                  <c:v>0.096708</c:v>
                 </c:pt>
               </c:numCache>
             </c:numRef>
@@ -2708,9 +2622,8 @@
                 <a:r>
                   <a:rPr lang="en-US" sz="800" b="0" i="0" u="sng" baseline="0">
                     <a:solidFill>
-                      <a:sysClr val="windowText" lastClr="000000"/>
+                      <a:schemeClr val="tx1"/>
                     </a:solidFill>
-                    <a:effectLst/>
                     <a:latin typeface="+mn-lt"/>
                   </a:rPr>
                   <a:t>First priority: Over cement</a:t>
@@ -2943,9 +2856,9 @@
           <c:xMode val="edge"/>
           <c:yMode val="edge"/>
           <c:x val="0.00507243579846637"/>
-          <c:y val="0.289732533433321"/>
+          <c:y val="0.285"/>
           <c:w val="0.971250836292522"/>
-          <c:h val="0.418760515512484"/>
+          <c:h val="0.442"/>
         </c:manualLayout>
       </c:layout>
       <c:barChart>
@@ -2982,19 +2895,19 @@
               <c:strCache>
                 <c:ptCount val="5"/>
                 <c:pt idx="0">
+                  <c:v>NIKE AIR MAX EXCEE (MS/WS)</c:v>
+                </c:pt>
+                <c:pt idx="1">
                   <c:v>NIKE INITIATOR (MS/WS)</c:v>
                 </c:pt>
-                <c:pt idx="1">
-                  <c:v>NIKE RUN DEFY (MS/WS)</c:v>
-                </c:pt>
                 <c:pt idx="2">
-                  <c:v>NIKE AIR MAX EXCEE (MS/WS)</c:v>
+                  <c:v>NIKE AIR MAX SC (MS/WS)</c:v>
                 </c:pt>
                 <c:pt idx="3">
+                  <c:v>NIKE AIR WINFLO 12 (MS/WS)</c:v>
+                </c:pt>
+                <c:pt idx="4">
                   <c:v>NIKE UPLIFT SC (MS/WS)</c:v>
-                </c:pt>
-                <c:pt idx="4">
-                  <c:v>NIKE AIR MAX SC (MS/WS)</c:v>
                 </c:pt>
               </c:strCache>
             </c:strRef>
@@ -3006,19 +2919,19 @@
                 <c:formatCode>0.00%</c:formatCode>
                 <c:ptCount val="5"/>
                 <c:pt idx="0">
-                  <c:v>0.030866</c:v>
+                  <c:v>0.030009</c:v>
                 </c:pt>
                 <c:pt idx="1">
-                  <c:v>0.020998</c:v>
+                  <c:v>0.017235</c:v>
                 </c:pt>
                 <c:pt idx="2">
-                  <c:v>0.019276</c:v>
+                  <c:v>0.013725</c:v>
                 </c:pt>
                 <c:pt idx="3">
-                  <c:v>0.009009</c:v>
+                  <c:v>0.012472</c:v>
                 </c:pt>
                 <c:pt idx="4">
-                  <c:v>0.007890</c:v>
+                  <c:v>0.012187</c:v>
                 </c:pt>
               </c:numCache>
             </c:numRef>
@@ -3321,9 +3234,9 @@
           <c:xMode val="edge"/>
           <c:yMode val="edge"/>
           <c:x val="0.00511663929435721"/>
-          <c:y val="0.191288949458241"/>
+          <c:y val="0.285"/>
           <c:w val="0.973010635509768"/>
-          <c:h val="0.51720421966485"/>
+          <c:h val="0.442"/>
         </c:manualLayout>
       </c:layout>
       <c:barChart>
@@ -3366,13 +3279,13 @@
                   <c:v>NIKE EBERNON LOW (MS/WS)</c:v>
                 </c:pt>
                 <c:pt idx="2">
-                  <c:v>NIKE AIR MAX SC (MS/WS)</c:v>
+                  <c:v>NIKE AIR MAX MOTION 2 (MS/WS)</c:v>
                 </c:pt>
                 <c:pt idx="3">
-                  <c:v>NIKE COURT VISION LOW (MS/WS)</c:v>
+                  <c:v>NIKE STAR RUNNER 5 (PS)</c:v>
                 </c:pt>
                 <c:pt idx="4">
-                  <c:v>NIKE AIR MAX MOTION 2 (MS/WS)</c:v>
+                  <c:v>NIKE COURT BOROUGH LOW RECRAFT (TD)</c:v>
                 </c:pt>
               </c:strCache>
             </c:strRef>
@@ -3384,19 +3297,19 @@
                 <c:formatCode>0.00%</c:formatCode>
                 <c:ptCount val="5"/>
                 <c:pt idx="0">
-                  <c:v>0.031774</c:v>
+                  <c:v>0.054453</c:v>
                 </c:pt>
                 <c:pt idx="1">
-                  <c:v>0.019854</c:v>
+                  <c:v>0.023969</c:v>
                 </c:pt>
                 <c:pt idx="2">
-                  <c:v>0.013731</c:v>
+                  <c:v>0.012725</c:v>
                 </c:pt>
                 <c:pt idx="3">
-                  <c:v>0.007499</c:v>
+                  <c:v>0.006618</c:v>
                 </c:pt>
                 <c:pt idx="4">
-                  <c:v>0.006691</c:v>
+                  <c:v>0.006526</c:v>
                 </c:pt>
               </c:numCache>
             </c:numRef>
@@ -3496,7 +3409,7 @@
         <c:axId val="-1252543328"/>
         <c:scaling>
           <c:orientation val="minMax"/>
-          <c:max val="0.05"/>
+          <c:max val="0.08"/>
           <c:min val="0"/>
         </c:scaling>
         <c:delete val="0"/>
@@ -3550,8 +3463,8 @@
         <c:manualLayout>
           <c:xMode val="edge"/>
           <c:yMode val="edge"/>
-          <c:x val="0.0560035532839097"/>
-          <c:y val="0.0152760952957803"/>
+          <c:x val="0.0600645231846019"/>
+          <c:y val="0.0259601924759405"/>
           <c:w val="0.166350867760473"/>
           <c:h val="0.167411886014248"/>
         </c:manualLayout>
@@ -3699,9 +3612,9 @@
           <c:xMode val="edge"/>
           <c:yMode val="edge"/>
           <c:x val="0.0116907901132242"/>
-          <c:y val="0.329859070787793"/>
+          <c:y val="0.285"/>
           <c:w val="0.977968488588049"/>
-          <c:h val="0.387335794779384"/>
+          <c:h val="0.442"/>
         </c:manualLayout>
       </c:layout>
       <c:barChart>
@@ -3741,16 +3654,16 @@
                   <c:v>NIKE COURT VISION LOW (MS/WS)</c:v>
                 </c:pt>
                 <c:pt idx="1">
-                  <c:v>AIR JORDAN 1 MID SE (GS)</c:v>
+                  <c:v>NIKE INITIATOR (MS/WS)</c:v>
                 </c:pt>
                 <c:pt idx="2">
                   <c:v>JORDAN 1 MID SE (PS/TD)</c:v>
                 </c:pt>
                 <c:pt idx="3">
-                  <c:v>NIKE INITIATOR (MS/WS)</c:v>
+                  <c:v>AIR JORDAN 1 LOW (MS/WS)</c:v>
                 </c:pt>
                 <c:pt idx="4">
-                  <c:v>AIR JORDAN 1 LOW (MS/WS)</c:v>
+                  <c:v>AIR JORDAN 1 LOW SE (GS)</c:v>
                 </c:pt>
               </c:strCache>
             </c:strRef>
@@ -3762,19 +3675,19 @@
                 <c:formatCode>0.00%</c:formatCode>
                 <c:ptCount val="5"/>
                 <c:pt idx="0">
-                  <c:v>0.009948</c:v>
+                  <c:v>0.010496</c:v>
                 </c:pt>
                 <c:pt idx="1">
-                  <c:v>0.006282</c:v>
+                  <c:v>0.008397</c:v>
                 </c:pt>
                 <c:pt idx="2">
-                  <c:v>0.006121</c:v>
+                  <c:v>0.004894</c:v>
                 </c:pt>
                 <c:pt idx="3">
-                  <c:v>0.006035</c:v>
+                  <c:v>0.004350</c:v>
                 </c:pt>
                 <c:pt idx="4">
-                  <c:v>0.004717</c:v>
+                  <c:v>0.003490</c:v>
                 </c:pt>
               </c:numCache>
             </c:numRef>
@@ -4161,9 +4074,9 @@
           </c:dLbls>
           <c:cat>
             <c:strRef>
-              <c:f>'Current month'!$C$1:$H$1</c:f>
+              <c:f>'Current month'!$C$1:$K$1</c:f>
               <c:strCache>
-                <c:ptCount val="6"/>
+                <c:ptCount val="9"/>
                 <c:pt idx="0">
                   <c:v>Jan</c:v>
                 </c:pt>
@@ -4181,16 +4094,25 @@
                 </c:pt>
                 <c:pt idx="5">
                   <c:v>Jun</c:v>
+                </c:pt>
+                <c:pt idx="6">
+                  <c:v>Jul</c:v>
+                </c:pt>
+                <c:pt idx="7">
+                  <c:v>Aug</c:v>
+                </c:pt>
+                <c:pt idx="8">
+                  <c:v>Sep</c:v>
                 </c:pt>
               </c:strCache>
             </c:strRef>
           </c:cat>
           <c:val>
             <c:numRef>
-              <c:f>'Current month'!$C$2:$H$2</c:f>
+              <c:f>'Current month'!$C$2:$K$2</c:f>
               <c:numCache>
                 <c:formatCode>#,##0</c:formatCode>
-                <c:ptCount val="6"/>
+                <c:ptCount val="9"/>
                 <c:pt idx="0">
                   <c:v>271598.0</c:v>
                 </c:pt>
@@ -4208,6 +4130,15 @@
                 </c:pt>
                 <c:pt idx="5">
                   <c:v>229614.0</c:v>
+                </c:pt>
+                <c:pt idx="6">
+                  <c:v>250538.0</c:v>
+                </c:pt>
+                <c:pt idx="7">
+                  <c:v>252237.0</c:v>
+                </c:pt>
+                <c:pt idx="8">
+                  <c:v>191303.0</c:v>
                 </c:pt>
               </c:numCache>
             </c:numRef>
@@ -4367,9 +4298,9 @@
           </c:dLbls>
           <c:cat>
             <c:strRef>
-              <c:f>'Current month'!$C$1:$H$1</c:f>
+              <c:f>'Current month'!$C$1:$K$1</c:f>
               <c:strCache>
-                <c:ptCount val="6"/>
+                <c:ptCount val="9"/>
                 <c:pt idx="0">
                   <c:v>Jan</c:v>
                 </c:pt>
@@ -4387,16 +4318,25 @@
                 </c:pt>
                 <c:pt idx="5">
                   <c:v>Jun</c:v>
+                </c:pt>
+                <c:pt idx="6">
+                  <c:v>Jul</c:v>
+                </c:pt>
+                <c:pt idx="7">
+                  <c:v>Aug</c:v>
+                </c:pt>
+                <c:pt idx="8">
+                  <c:v>Sep</c:v>
                 </c:pt>
               </c:strCache>
             </c:strRef>
           </c:cat>
           <c:val>
             <c:numRef>
-              <c:f>'Current month'!$C$9:$H$9</c:f>
+              <c:f>'Current month'!$C$9:$K$9</c:f>
               <c:numCache>
                 <c:formatCode>#,##0</c:formatCode>
-                <c:ptCount val="6"/>
+                <c:ptCount val="9"/>
                 <c:pt idx="0">
                   <c:v>41519.0</c:v>
                 </c:pt>
@@ -4414,6 +4354,15 @@
                 </c:pt>
                 <c:pt idx="5">
                   <c:v>35819.0</c:v>
+                </c:pt>
+                <c:pt idx="6">
+                  <c:v>39321.0</c:v>
+                </c:pt>
+                <c:pt idx="7">
+                  <c:v>40405.0</c:v>
+                </c:pt>
+                <c:pt idx="8">
+                  <c:v>30535.0</c:v>
                 </c:pt>
               </c:numCache>
             </c:numRef>
@@ -4531,9 +4480,9 @@
           <c:smooth val="0"/>
           <c:cat>
             <c:strRef>
-              <c:f>'Current month'!$C$1:$H$1</c:f>
+              <c:f>'Current month'!$C$1:$K$1</c:f>
               <c:strCache>
-                <c:ptCount val="6"/>
+                <c:ptCount val="9"/>
                 <c:pt idx="0">
                   <c:v>Jan</c:v>
                 </c:pt>
@@ -4551,16 +4500,25 @@
                 </c:pt>
                 <c:pt idx="5">
                   <c:v>Jun</c:v>
+                </c:pt>
+                <c:pt idx="6">
+                  <c:v>Jul</c:v>
+                </c:pt>
+                <c:pt idx="7">
+                  <c:v>Aug</c:v>
+                </c:pt>
+                <c:pt idx="8">
+                  <c:v>Sep</c:v>
                 </c:pt>
               </c:strCache>
             </c:strRef>
           </c:cat>
           <c:val>
             <c:numRef>
-              <c:f>'Current month'!$C$16:$H$16</c:f>
+              <c:f>'Current month'!$C$16:$K$16</c:f>
               <c:numCache>
                 <c:formatCode>0.00%</c:formatCode>
-                <c:ptCount val="6"/>
+                <c:ptCount val="9"/>
                 <c:pt idx="0">
                   <c:v>0.8471306857929735</c:v>
                 </c:pt>
@@ -4578,6 +4536,15 @@
                 </c:pt>
                 <c:pt idx="5">
                   <c:v>0.8440034144259496</c:v>
+                </c:pt>
+                <c:pt idx="6">
+                  <c:v>0.8430537483335862</c:v>
+                </c:pt>
+                <c:pt idx="7">
+                  <c:v>0.8398133501429211</c:v>
+                </c:pt>
+                <c:pt idx="8">
+                  <c:v>0.8403841027061781</c:v>
                 </c:pt>
               </c:numCache>
             </c:numRef>
@@ -5023,9 +4990,9 @@
           </c:dLbls>
           <c:cat>
             <c:strRef>
-              <c:f>'Current month'!$C$1:$H$1</c:f>
+              <c:f>'Current month'!$C$1:$K$1</c:f>
               <c:strCache>
-                <c:ptCount val="6"/>
+                <c:ptCount val="9"/>
                 <c:pt idx="0">
                   <c:v>Jan</c:v>
                 </c:pt>
@@ -5043,16 +5010,25 @@
                 </c:pt>
                 <c:pt idx="5">
                   <c:v>Jun</c:v>
+                </c:pt>
+                <c:pt idx="6">
+                  <c:v>Jul</c:v>
+                </c:pt>
+                <c:pt idx="7">
+                  <c:v>Aug</c:v>
+                </c:pt>
+                <c:pt idx="8">
+                  <c:v>Sep</c:v>
                 </c:pt>
               </c:strCache>
             </c:strRef>
           </c:cat>
           <c:val>
             <c:numRef>
-              <c:f>'Current month'!$C$3:$H$3</c:f>
+              <c:f>'Current month'!$C$3:$K$3</c:f>
               <c:numCache>
                 <c:formatCode>#,##0</c:formatCode>
-                <c:ptCount val="6"/>
+                <c:ptCount val="9"/>
                 <c:pt idx="0">
                   <c:v>215017.0</c:v>
                 </c:pt>
@@ -5070,6 +5046,15 @@
                 </c:pt>
                 <c:pt idx="5">
                   <c:v>187587.0</c:v>
+                </c:pt>
+                <c:pt idx="6">
+                  <c:v>185739.0</c:v>
+                </c:pt>
+                <c:pt idx="7">
+                  <c:v>187637.0</c:v>
+                </c:pt>
+                <c:pt idx="8">
+                  <c:v>175514.0</c:v>
                 </c:pt>
               </c:numCache>
             </c:numRef>
@@ -5156,9 +5141,9 @@
           </c:dLbls>
           <c:cat>
             <c:strRef>
-              <c:f>'Current month'!$C$1:$H$1</c:f>
+              <c:f>'Current month'!$C$1:$K$1</c:f>
               <c:strCache>
-                <c:ptCount val="6"/>
+                <c:ptCount val="9"/>
                 <c:pt idx="0">
                   <c:v>Jan</c:v>
                 </c:pt>
@@ -5176,16 +5161,25 @@
                 </c:pt>
                 <c:pt idx="5">
                   <c:v>Jun</c:v>
+                </c:pt>
+                <c:pt idx="6">
+                  <c:v>Jul</c:v>
+                </c:pt>
+                <c:pt idx="7">
+                  <c:v>Aug</c:v>
+                </c:pt>
+                <c:pt idx="8">
+                  <c:v>Sep</c:v>
                 </c:pt>
               </c:strCache>
             </c:strRef>
           </c:cat>
           <c:val>
             <c:numRef>
-              <c:f>'Current month'!$C$10:$H$10</c:f>
+              <c:f>'Current month'!$C$10:$K$10</c:f>
               <c:numCache>
                 <c:formatCode>#,##0</c:formatCode>
-                <c:ptCount val="6"/>
+                <c:ptCount val="9"/>
                 <c:pt idx="0">
                   <c:v>20033.0</c:v>
                 </c:pt>
@@ -5203,6 +5197,15 @@
                 </c:pt>
                 <c:pt idx="5">
                   <c:v>26824.0</c:v>
+                </c:pt>
+                <c:pt idx="6">
+                  <c:v>26996.0</c:v>
+                </c:pt>
+                <c:pt idx="7">
+                  <c:v>27355.0</c:v>
+                </c:pt>
+                <c:pt idx="8">
+                  <c:v>25464.0</c:v>
                 </c:pt>
               </c:numCache>
             </c:numRef>
@@ -5320,9 +5323,9 @@
           <c:smooth val="0"/>
           <c:cat>
             <c:strRef>
-              <c:f>'Current month'!$C$1:$H$1</c:f>
+              <c:f>'Current month'!$C$1:$K$1</c:f>
               <c:strCache>
-                <c:ptCount val="6"/>
+                <c:ptCount val="9"/>
                 <c:pt idx="0">
                   <c:v>Jan</c:v>
                 </c:pt>
@@ -5340,16 +5343,25 @@
                 </c:pt>
                 <c:pt idx="5">
                   <c:v>Jun</c:v>
+                </c:pt>
+                <c:pt idx="6">
+                  <c:v>Jul</c:v>
+                </c:pt>
+                <c:pt idx="7">
+                  <c:v>Aug</c:v>
+                </c:pt>
+                <c:pt idx="8">
+                  <c:v>Sep</c:v>
                 </c:pt>
               </c:strCache>
             </c:strRef>
           </c:cat>
           <c:val>
             <c:numRef>
-              <c:f>'Current month'!$C$17:$H$17</c:f>
+              <c:f>'Current month'!$C$17:$K$17</c:f>
               <c:numCache>
                 <c:formatCode>0.00%</c:formatCode>
-                <c:ptCount val="6"/>
+                <c:ptCount val="9"/>
                 <c:pt idx="0">
                   <c:v>0.9068306226949497</c:v>
                 </c:pt>
@@ -5367,6 +5379,15 @@
                 </c:pt>
                 <c:pt idx="5">
                   <c:v>0.8570050163390853</c:v>
+                </c:pt>
+                <c:pt idx="6">
+                  <c:v>0.8546562649739688</c:v>
+                </c:pt>
+                <c:pt idx="7">
+                  <c:v>0.8542131882304662</c:v>
+                </c:pt>
+                <c:pt idx="8">
+                  <c:v>0.8549175564342446</c:v>
                 </c:pt>
               </c:numCache>
             </c:numRef>
@@ -5802,9 +5823,9 @@
           </c:dLbls>
           <c:cat>
             <c:strRef>
-              <c:f>'Current month'!$C$1:$H$1</c:f>
+              <c:f>'Current month'!$C$1:$K$1</c:f>
               <c:strCache>
-                <c:ptCount val="6"/>
+                <c:ptCount val="9"/>
                 <c:pt idx="0">
                   <c:v>Jan</c:v>
                 </c:pt>
@@ -5822,16 +5843,25 @@
                 </c:pt>
                 <c:pt idx="5">
                   <c:v>Jun</c:v>
+                </c:pt>
+                <c:pt idx="6">
+                  <c:v>Jul</c:v>
+                </c:pt>
+                <c:pt idx="7">
+                  <c:v>Aug</c:v>
+                </c:pt>
+                <c:pt idx="8">
+                  <c:v>Sep</c:v>
                 </c:pt>
               </c:strCache>
             </c:strRef>
           </c:cat>
           <c:val>
             <c:numRef>
-              <c:f>'Current month'!$C$4:$H$4</c:f>
+              <c:f>'Current month'!$C$4:$K$4</c:f>
               <c:numCache>
                 <c:formatCode>#,##0</c:formatCode>
-                <c:ptCount val="6"/>
+                <c:ptCount val="9"/>
                 <c:pt idx="0">
                   <c:v>113263.0</c:v>
                 </c:pt>
@@ -5849,6 +5879,15 @@
                 </c:pt>
                 <c:pt idx="5">
                   <c:v>91617.0</c:v>
+                </c:pt>
+                <c:pt idx="6">
+                  <c:v>113846.0</c:v>
+                </c:pt>
+                <c:pt idx="7">
+                  <c:v>92175.0</c:v>
+                </c:pt>
+                <c:pt idx="8">
+                  <c:v>97919.0</c:v>
                 </c:pt>
               </c:numCache>
             </c:numRef>
@@ -5935,9 +5974,9 @@
           </c:dLbls>
           <c:cat>
             <c:strRef>
-              <c:f>'Current month'!$C$1:$H$1</c:f>
+              <c:f>'Current month'!$C$1:$K$1</c:f>
               <c:strCache>
-                <c:ptCount val="6"/>
+                <c:ptCount val="9"/>
                 <c:pt idx="0">
                   <c:v>Jan</c:v>
                 </c:pt>
@@ -5955,16 +5994,25 @@
                 </c:pt>
                 <c:pt idx="5">
                   <c:v>Jun</c:v>
+                </c:pt>
+                <c:pt idx="6">
+                  <c:v>Jul</c:v>
+                </c:pt>
+                <c:pt idx="7">
+                  <c:v>Aug</c:v>
+                </c:pt>
+                <c:pt idx="8">
+                  <c:v>Sep</c:v>
                 </c:pt>
               </c:strCache>
             </c:strRef>
           </c:cat>
           <c:val>
             <c:numRef>
-              <c:f>'Current month'!$C$11:$H$11</c:f>
+              <c:f>'Current month'!$C$11:$K$11</c:f>
               <c:numCache>
                 <c:formatCode>#,##0</c:formatCode>
-                <c:ptCount val="6"/>
+                <c:ptCount val="9"/>
                 <c:pt idx="0">
                   <c:v>7879.0</c:v>
                 </c:pt>
@@ -5982,6 +6030,15 @@
                 </c:pt>
                 <c:pt idx="5">
                   <c:v>9379.0</c:v>
+                </c:pt>
+                <c:pt idx="6">
+                  <c:v>11891.0</c:v>
+                </c:pt>
+                <c:pt idx="7">
+                  <c:v>11421.0</c:v>
+                </c:pt>
+                <c:pt idx="8">
+                  <c:v>12584.0</c:v>
                 </c:pt>
               </c:numCache>
             </c:numRef>
@@ -6099,9 +6156,9 @@
           <c:smooth val="0"/>
           <c:cat>
             <c:strRef>
-              <c:f>'Current month'!$C$1:$H$1</c:f>
+              <c:f>'Current month'!$C$1:$K$1</c:f>
               <c:strCache>
-                <c:ptCount val="6"/>
+                <c:ptCount val="9"/>
                 <c:pt idx="0">
                   <c:v>Jan</c:v>
                 </c:pt>
@@ -6119,16 +6176,25 @@
                 </c:pt>
                 <c:pt idx="5">
                   <c:v>Jun</c:v>
+                </c:pt>
+                <c:pt idx="6">
+                  <c:v>Jul</c:v>
+                </c:pt>
+                <c:pt idx="7">
+                  <c:v>Aug</c:v>
+                </c:pt>
+                <c:pt idx="8">
+                  <c:v>Sep</c:v>
                 </c:pt>
               </c:strCache>
             </c:strRef>
           </c:cat>
           <c:val>
             <c:numRef>
-              <c:f>'Current month'!$C$18:$H$18</c:f>
+              <c:f>'Current month'!$C$18:$K$18</c:f>
               <c:numCache>
                 <c:formatCode>0.00%</c:formatCode>
-                <c:ptCount val="6"/>
+                <c:ptCount val="9"/>
                 <c:pt idx="0">
                   <c:v>0.9304362413144628</c:v>
                 </c:pt>
@@ -6146,6 +6212,15 @@
                 </c:pt>
                 <c:pt idx="5">
                   <c:v>0.8976281694445354</c:v>
+                </c:pt>
+                <c:pt idx="6">
+                  <c:v>0.8955518858809268</c:v>
+                </c:pt>
+                <c:pt idx="7">
+                  <c:v>0.8760943856794141</c:v>
+                </c:pt>
+                <c:pt idx="8">
+                  <c:v>0.8714856156619246</c:v>
                 </c:pt>
               </c:numCache>
             </c:numRef>
@@ -6585,9 +6660,9 @@
           </c:dLbls>
           <c:cat>
             <c:strRef>
-              <c:f>'Current month'!$C$1:$H$1</c:f>
+              <c:f>'Current month'!$C$1:$K$1</c:f>
               <c:strCache>
-                <c:ptCount val="6"/>
+                <c:ptCount val="9"/>
                 <c:pt idx="0">
                   <c:v>Jan</c:v>
                 </c:pt>
@@ -6605,16 +6680,25 @@
                 </c:pt>
                 <c:pt idx="5">
                   <c:v>Jun</c:v>
+                </c:pt>
+                <c:pt idx="6">
+                  <c:v>Jul</c:v>
+                </c:pt>
+                <c:pt idx="7">
+                  <c:v>Aug</c:v>
+                </c:pt>
+                <c:pt idx="8">
+                  <c:v>Sep</c:v>
                 </c:pt>
               </c:strCache>
             </c:strRef>
           </c:cat>
           <c:val>
             <c:numRef>
-              <c:f>'Current month'!$C$5:$H$5</c:f>
+              <c:f>'Current month'!$C$5:$K$5</c:f>
               <c:numCache>
                 <c:formatCode>#,##0</c:formatCode>
-                <c:ptCount val="6"/>
+                <c:ptCount val="9"/>
                 <c:pt idx="0">
                   <c:v>104684.0</c:v>
                 </c:pt>
@@ -6632,6 +6716,15 @@
                 </c:pt>
                 <c:pt idx="5">
                   <c:v>93287.0</c:v>
+                </c:pt>
+                <c:pt idx="6">
+                  <c:v>111473.0</c:v>
+                </c:pt>
+                <c:pt idx="7">
+                  <c:v>76104.0</c:v>
+                </c:pt>
+                <c:pt idx="8">
+                  <c:v>79079.0</c:v>
                 </c:pt>
               </c:numCache>
             </c:numRef>
@@ -6718,9 +6811,9 @@
           </c:dLbls>
           <c:cat>
             <c:strRef>
-              <c:f>'Current month'!$C$1:$H$1</c:f>
+              <c:f>'Current month'!$C$1:$K$1</c:f>
               <c:strCache>
-                <c:ptCount val="6"/>
+                <c:ptCount val="9"/>
                 <c:pt idx="0">
                   <c:v>Jan</c:v>
                 </c:pt>
@@ -6738,16 +6831,25 @@
                 </c:pt>
                 <c:pt idx="5">
                   <c:v>Jun</c:v>
+                </c:pt>
+                <c:pt idx="6">
+                  <c:v>Jul</c:v>
+                </c:pt>
+                <c:pt idx="7">
+                  <c:v>Aug</c:v>
+                </c:pt>
+                <c:pt idx="8">
+                  <c:v>Sep</c:v>
                 </c:pt>
               </c:strCache>
             </c:strRef>
           </c:cat>
           <c:val>
             <c:numRef>
-              <c:f>'Current month'!$C$12:$H$12</c:f>
+              <c:f>'Current month'!$C$12:$K$12</c:f>
               <c:numCache>
                 <c:formatCode>#,##0</c:formatCode>
-                <c:ptCount val="6"/>
+                <c:ptCount val="9"/>
                 <c:pt idx="0">
                   <c:v>6002.0</c:v>
                 </c:pt>
@@ -6765,6 +6867,15 @@
                 </c:pt>
                 <c:pt idx="5">
                   <c:v>5475.0</c:v>
+                </c:pt>
+                <c:pt idx="6">
+                  <c:v>6539.0</c:v>
+                </c:pt>
+                <c:pt idx="7">
+                  <c:v>4503.0</c:v>
+                </c:pt>
+                <c:pt idx="8">
+                  <c:v>4580.0</c:v>
                 </c:pt>
               </c:numCache>
             </c:numRef>
@@ -6882,9 +6993,9 @@
           <c:smooth val="0"/>
           <c:cat>
             <c:strRef>
-              <c:f>'Current month'!$C$1:$H$1</c:f>
+              <c:f>'Current month'!$C$1:$K$1</c:f>
               <c:strCache>
-                <c:ptCount val="6"/>
+                <c:ptCount val="9"/>
                 <c:pt idx="0">
                   <c:v>Jan</c:v>
                 </c:pt>
@@ -6902,16 +7013,25 @@
                 </c:pt>
                 <c:pt idx="5">
                   <c:v>Jun</c:v>
+                </c:pt>
+                <c:pt idx="6">
+                  <c:v>Jul</c:v>
+                </c:pt>
+                <c:pt idx="7">
+                  <c:v>Aug</c:v>
+                </c:pt>
+                <c:pt idx="8">
+                  <c:v>Sep</c:v>
                 </c:pt>
               </c:strCache>
             </c:strRef>
           </c:cat>
           <c:val>
             <c:numRef>
-              <c:f>'Current month'!$C$19:$H$19</c:f>
+              <c:f>'Current month'!$C$19:$K$19</c:f>
               <c:numCache>
                 <c:formatCode>0.00%</c:formatCode>
-                <c:ptCount val="6"/>
+                <c:ptCount val="9"/>
                 <c:pt idx="0">
                   <c:v>0.9426655458331741</c:v>
                 </c:pt>
@@ -6929,6 +7049,15 @@
                 </c:pt>
                 <c:pt idx="5">
                   <c:v>0.9413101503960895</c:v>
+                </c:pt>
+                <c:pt idx="6">
+                  <c:v>0.9413400554394338</c:v>
+                </c:pt>
+                <c:pt idx="7">
+                  <c:v>0.9408309681488489</c:v>
+                </c:pt>
+                <c:pt idx="8">
+                  <c:v>0.9420832332224738</c:v>
                 </c:pt>
               </c:numCache>
             </c:numRef>
@@ -7302,7 +7431,7 @@
           <c:order val="0"/>
           <c:tx>
             <c:strRef>
-              <c:f>'Current month'!$M$21</c:f>
+              <c:f>'HFPA'!$M$21</c:f>
               <c:strCache>
                 <c:ptCount val="1"/>
                 <c:pt idx="0">
@@ -7355,47 +7484,47 @@
           </c:dLbls>
           <c:cat>
             <c:strRef>
-              <c:f>'Current month'!$L$22:$L$26</c:f>
+              <c:f>'HFPA'!$L$22:$L$26</c:f>
               <c:strCache>
                 <c:ptCount val="5"/>
                 <c:pt idx="0">
-                  <c:v>NIKE AIR WINFLO 12 (MS/WS)</c:v>
+                  <c:v>NIKE SB FORCE 58</c:v>
                 </c:pt>
                 <c:pt idx="1">
-                  <c:v>JORDAN SPIZIKE LOW (GS)</c:v>
+                  <c:v>NIKE MANOA LEATHER</c:v>
                 </c:pt>
                 <c:pt idx="2">
-                  <c:v>NIKE SB FORCE 58</c:v>
+                  <c:v>WMNS BENASSI JDI</c:v>
                 </c:pt>
                 <c:pt idx="3">
+                  <c:v>JORDAN TRUE FLIGHT (MS)</c:v>
+                </c:pt>
+                <c:pt idx="4">
                   <c:v>AIR JORDAN 1 LOW SE (MS/WS)</c:v>
-                </c:pt>
-                <c:pt idx="4">
-                  <c:v>WMNS BENASSI JDI</c:v>
                 </c:pt>
               </c:strCache>
             </c:strRef>
           </c:cat>
           <c:val>
             <c:numRef>
-              <c:f>'Current month'!$M$22:$M$26</c:f>
+              <c:f>'HFPA'!$M$22:$M$26</c:f>
               <c:numCache>
                 <c:formatCode>0.00%</c:formatCode>
                 <c:ptCount val="5"/>
                 <c:pt idx="0">
-                  <c:v>0.146748</c:v>
+                  <c:v>0.231505</c:v>
                 </c:pt>
                 <c:pt idx="1">
-                  <c:v>0.180101</c:v>
+                  <c:v>0.174399</c:v>
                 </c:pt>
                 <c:pt idx="2">
-                  <c:v>0.220952</c:v>
+                  <c:v>0.164248</c:v>
                 </c:pt>
                 <c:pt idx="3">
-                  <c:v>0.172078</c:v>
+                  <c:v>0.156012</c:v>
                 </c:pt>
                 <c:pt idx="4">
-                  <c:v>0.206529</c:v>
+                  <c:v>0.222048</c:v>
                 </c:pt>
               </c:numCache>
             </c:numRef>
@@ -7406,7 +7535,7 @@
           <c:order val="1"/>
           <c:tx>
             <c:strRef>
-              <c:f>'Current month'!$N$21</c:f>
+              <c:f>'HFPA'!$N$21</c:f>
               <c:strCache>
                 <c:ptCount val="1"/>
                 <c:pt idx="0">
@@ -7459,44 +7588,47 @@
           </c:dLbls>
           <c:cat>
             <c:strRef>
-              <c:f>'Current month'!$L$22:$L$26</c:f>
+              <c:f>'HFPA'!$L$22:$L$26</c:f>
               <c:strCache>
                 <c:ptCount val="5"/>
                 <c:pt idx="0">
-                  <c:v>NIKE AIR WINFLO 12 (MS/WS)</c:v>
+                  <c:v>NIKE SB FORCE 58</c:v>
                 </c:pt>
                 <c:pt idx="1">
-                  <c:v>JORDAN SPIZIKE LOW (GS)</c:v>
+                  <c:v>NIKE MANOA LEATHER</c:v>
                 </c:pt>
                 <c:pt idx="2">
-                  <c:v>NIKE SB FORCE 58</c:v>
+                  <c:v>WMNS BENASSI JDI</c:v>
                 </c:pt>
                 <c:pt idx="3">
+                  <c:v>JORDAN TRUE FLIGHT (MS)</c:v>
+                </c:pt>
+                <c:pt idx="4">
                   <c:v>AIR JORDAN 1 LOW SE (MS/WS)</c:v>
-                </c:pt>
-                <c:pt idx="4">
-                  <c:v>WMNS BENASSI JDI</c:v>
                 </c:pt>
               </c:strCache>
             </c:strRef>
           </c:cat>
           <c:val>
             <c:numRef>
-              <c:f>'Current month'!$N$22:$N$26</c:f>
+              <c:f>'HFPA'!$N$22:$N$26</c:f>
               <c:numCache>
                 <c:formatCode>0.00%</c:formatCode>
                 <c:ptCount val="5"/>
                 <c:pt idx="0">
-                  <c:v>0.129491</c:v>
+                  <c:v>0.242073</c:v>
                 </c:pt>
                 <c:pt idx="1">
-                  <c:v>0.143577</c:v>
+                  <c:v>0.137507</c:v>
                 </c:pt>
                 <c:pt idx="2">
-                  <c:v>0.235130</c:v>
+                  <c:v>0.141821</c:v>
                 </c:pt>
                 <c:pt idx="3">
-                  <c:v>0.168405</c:v>
+                  <c:v>0.110350</c:v>
+                </c:pt>
+                <c:pt idx="4">
+                  <c:v>0.203284</c:v>
                 </c:pt>
               </c:numCache>
             </c:numRef>
@@ -7507,197 +7639,7 @@
           <c:order val="2"/>
           <c:tx>
             <c:strRef>
-              <c:f>'Current month'!$O$21</c:f>
-              <c:strCache>
-                <c:ptCount val="1"/>
-                <c:pt idx="0">
-                  <c:v>Rocking</c:v>
-                </c:pt>
-              </c:strCache>
-            </c:strRef>
-          </c:tx>
-          <c:spPr>
-            <a:solidFill>
-              <a:srgbClr val="EAD700"/>
-            </a:solidFill>
-            <a:ln>
-              <a:noFill/>
-            </a:ln>
-          </c:spPr>
-          <c:invertIfNegative val="0"/>
-          <c:dLbls>
-            <c:spPr>
-              <a:noFill/>
-              <a:ln>
-                <a:noFill/>
-              </a:ln>
-            </c:spPr>
-            <c:txPr>
-              <a:bodyPr rot="0" spcFirstLastPara="1" vertOverflow="ellipsis" vert="horz" wrap="square" lIns="19050" tIns="9525" rIns="19050" bIns="9525" anchor="ctr" anchorCtr="1">
-                <a:spAutoFit/>
-              </a:bodyPr>
-              <a:lstStyle/>
-              <a:p>
-                <a:pPr>
-                  <a:defRPr lang="en-US" sz="700" b="1" i="0" baseline="0">
-                    <a:solidFill>
-                      <a:srgbClr val="000000"/>
-                    </a:solidFill>
-                    <a:latin typeface="Calibri"/>
-                  </a:defRPr>
-                </a:pPr>
-              </a:p>
-            </c:txPr>
-            <c:numFmt formatCode="0.00%" sourceLinked="0"/>
-            <c:dLblPos val="ctr"/>
-            <c:showLegendKey val="0"/>
-            <c:showVal val="1"/>
-            <c:showCatName val="0"/>
-            <c:showSerName val="0"/>
-            <c:showPercent val="0"/>
-            <c:showBubbleSize val="0"/>
-            <c:showLeaderLines val="0"/>
-          </c:dLbls>
-          <c:cat>
-            <c:strRef>
-              <c:f>'Current month'!$L$22:$L$26</c:f>
-              <c:strCache>
-                <c:ptCount val="5"/>
-                <c:pt idx="0">
-                  <c:v>NIKE AIR WINFLO 12 (MS/WS)</c:v>
-                </c:pt>
-                <c:pt idx="1">
-                  <c:v>JORDAN SPIZIKE LOW (GS)</c:v>
-                </c:pt>
-                <c:pt idx="2">
-                  <c:v>NIKE SB FORCE 58</c:v>
-                </c:pt>
-                <c:pt idx="3">
-                  <c:v>AIR JORDAN 1 LOW SE (MS/WS)</c:v>
-                </c:pt>
-                <c:pt idx="4">
-                  <c:v>WMNS BENASSI JDI</c:v>
-                </c:pt>
-              </c:strCache>
-            </c:strRef>
-          </c:cat>
-          <c:val>
-            <c:numRef>
-              <c:f>'Current month'!$O$22:$O$26</c:f>
-              <c:numCache>
-                <c:formatCode>0.00%</c:formatCode>
-                <c:ptCount val="5"/>
-                <c:pt idx="3">
-                  <c:v>0.126276</c:v>
-                </c:pt>
-                <c:pt idx="4">
-                  <c:v>0.149752</c:v>
-                </c:pt>
-              </c:numCache>
-            </c:numRef>
-          </c:val>
-        </c:ser>
-        <c:ser>
-          <c:idx val="3"/>
-          <c:order val="3"/>
-          <c:tx>
-            <c:strRef>
-              <c:f>'Current month'!$P$21</c:f>
-              <c:strCache>
-                <c:ptCount val="1"/>
-                <c:pt idx="0">
-                  <c:v>Thread end</c:v>
-                </c:pt>
-              </c:strCache>
-            </c:strRef>
-          </c:tx>
-          <c:spPr>
-            <a:solidFill>
-              <a:srgbClr val="4F7FBD"/>
-            </a:solidFill>
-            <a:ln>
-              <a:noFill/>
-            </a:ln>
-          </c:spPr>
-          <c:invertIfNegative val="0"/>
-          <c:dLbls>
-            <c:spPr>
-              <a:noFill/>
-              <a:ln>
-                <a:noFill/>
-              </a:ln>
-            </c:spPr>
-            <c:txPr>
-              <a:bodyPr rot="0" spcFirstLastPara="1" vertOverflow="ellipsis" vert="horz" wrap="square" lIns="19050" tIns="9525" rIns="19050" bIns="9525" anchor="ctr" anchorCtr="1">
-                <a:spAutoFit/>
-              </a:bodyPr>
-              <a:lstStyle/>
-              <a:p>
-                <a:pPr>
-                  <a:defRPr lang="en-US" sz="700" b="1" i="0" baseline="0">
-                    <a:solidFill>
-                      <a:srgbClr val="FFFFFF"/>
-                    </a:solidFill>
-                    <a:latin typeface="Calibri"/>
-                  </a:defRPr>
-                </a:pPr>
-              </a:p>
-            </c:txPr>
-            <c:numFmt formatCode="0.00%" sourceLinked="0"/>
-            <c:dLblPos val="ctr"/>
-            <c:showLegendKey val="0"/>
-            <c:showVal val="1"/>
-            <c:showCatName val="0"/>
-            <c:showSerName val="0"/>
-            <c:showPercent val="0"/>
-            <c:showBubbleSize val="0"/>
-            <c:showLeaderLines val="0"/>
-          </c:dLbls>
-          <c:cat>
-            <c:strRef>
-              <c:f>'Current month'!$L$22:$L$26</c:f>
-              <c:strCache>
-                <c:ptCount val="5"/>
-                <c:pt idx="0">
-                  <c:v>NIKE AIR WINFLO 12 (MS/WS)</c:v>
-                </c:pt>
-                <c:pt idx="1">
-                  <c:v>JORDAN SPIZIKE LOW (GS)</c:v>
-                </c:pt>
-                <c:pt idx="2">
-                  <c:v>NIKE SB FORCE 58</c:v>
-                </c:pt>
-                <c:pt idx="3">
-                  <c:v>AIR JORDAN 1 LOW SE (MS/WS)</c:v>
-                </c:pt>
-                <c:pt idx="4">
-                  <c:v>WMNS BENASSI JDI</c:v>
-                </c:pt>
-              </c:strCache>
-            </c:strRef>
-          </c:cat>
-          <c:val>
-            <c:numRef>
-              <c:f>'Current month'!$P$22:$P$26</c:f>
-              <c:numCache>
-                <c:formatCode>0.00%</c:formatCode>
-                <c:ptCount val="5"/>
-                <c:pt idx="0">
-                  <c:v>0.097844</c:v>
-                </c:pt>
-                <c:pt idx="1">
-                  <c:v>0.154912</c:v>
-                </c:pt>
-              </c:numCache>
-            </c:numRef>
-          </c:val>
-        </c:ser>
-        <c:ser>
-          <c:idx val="4"/>
-          <c:order val="4"/>
-          <c:tx>
-            <c:strRef>
-              <c:f>'Current month'!$Q$21</c:f>
+              <c:f>'HFPA'!$O$21</c:f>
               <c:strCache>
                 <c:ptCount val="1"/>
                 <c:pt idx="0">
@@ -7750,57 +7692,152 @@
           </c:dLbls>
           <c:cat>
             <c:strRef>
-              <c:f>'Current month'!$L$22:$L$26</c:f>
+              <c:f>'HFPA'!$L$22:$L$26</c:f>
               <c:strCache>
                 <c:ptCount val="5"/>
                 <c:pt idx="0">
-                  <c:v>NIKE AIR WINFLO 12 (MS/WS)</c:v>
+                  <c:v>NIKE SB FORCE 58</c:v>
                 </c:pt>
                 <c:pt idx="1">
-                  <c:v>JORDAN SPIZIKE LOW (GS)</c:v>
+                  <c:v>NIKE MANOA LEATHER</c:v>
                 </c:pt>
                 <c:pt idx="2">
-                  <c:v>NIKE SB FORCE 58</c:v>
+                  <c:v>WMNS BENASSI JDI</c:v>
                 </c:pt>
                 <c:pt idx="3">
+                  <c:v>JORDAN TRUE FLIGHT (MS)</c:v>
+                </c:pt>
+                <c:pt idx="4">
                   <c:v>AIR JORDAN 1 LOW SE (MS/WS)</c:v>
-                </c:pt>
-                <c:pt idx="4">
-                  <c:v>WMNS BENASSI JDI</c:v>
                 </c:pt>
               </c:strCache>
             </c:strRef>
           </c:cat>
           <c:val>
             <c:numRef>
-              <c:f>'Current month'!$Q$22:$Q$26</c:f>
+              <c:f>'HFPA'!$O$22:$O$26</c:f>
               <c:numCache>
                 <c:formatCode>0.00%</c:formatCode>
                 <c:ptCount val="5"/>
-                <c:pt idx="2">
-                  <c:v>0.126007</c:v>
+                <c:pt idx="0">
+                  <c:v>0.117262</c:v>
+                </c:pt>
+                <c:pt idx="4">
+                  <c:v>0.148554</c:v>
                 </c:pt>
               </c:numCache>
             </c:numRef>
           </c:val>
         </c:ser>
         <c:ser>
-          <c:idx val="5"/>
-          <c:order val="5"/>
+          <c:idx val="3"/>
+          <c:order val="3"/>
           <c:tx>
             <c:strRef>
-              <c:f>'Current month'!$R$21</c:f>
+              <c:f>'HFPA'!$P$21</c:f>
               <c:strCache>
                 <c:ptCount val="1"/>
                 <c:pt idx="0">
-                  <c:v>Midsole/Outsole to upper bond gap</c:v>
+                  <c:v>Heel/Tip height inconsistent</c:v>
                 </c:pt>
               </c:strCache>
             </c:strRef>
           </c:tx>
           <c:spPr>
             <a:solidFill>
-              <a:srgbClr val="F79646"/>
+              <a:srgbClr val="336A4E"/>
+            </a:solidFill>
+            <a:ln>
+              <a:noFill/>
+            </a:ln>
+          </c:spPr>
+          <c:invertIfNegative val="0"/>
+          <c:dLbls>
+            <c:spPr>
+              <a:noFill/>
+              <a:ln>
+                <a:noFill/>
+              </a:ln>
+            </c:spPr>
+            <c:txPr>
+              <a:bodyPr rot="0" spcFirstLastPara="1" vertOverflow="ellipsis" vert="horz" wrap="square" lIns="19050" tIns="9525" rIns="19050" bIns="9525" anchor="ctr" anchorCtr="1">
+                <a:spAutoFit/>
+              </a:bodyPr>
+              <a:lstStyle/>
+              <a:p>
+                <a:pPr>
+                  <a:defRPr lang="en-US" sz="700" b="1" i="0" baseline="0">
+                    <a:solidFill>
+                      <a:srgbClr val="FFFFFF"/>
+                    </a:solidFill>
+                    <a:latin typeface="Calibri"/>
+                  </a:defRPr>
+                </a:pPr>
+              </a:p>
+            </c:txPr>
+            <c:numFmt formatCode="0.00%" sourceLinked="0"/>
+            <c:dLblPos val="ctr"/>
+            <c:showLegendKey val="0"/>
+            <c:showVal val="1"/>
+            <c:showCatName val="0"/>
+            <c:showSerName val="0"/>
+            <c:showPercent val="0"/>
+            <c:showBubbleSize val="0"/>
+            <c:showLeaderLines val="0"/>
+          </c:dLbls>
+          <c:cat>
+            <c:strRef>
+              <c:f>'HFPA'!$L$22:$L$26</c:f>
+              <c:strCache>
+                <c:ptCount val="5"/>
+                <c:pt idx="0">
+                  <c:v>NIKE SB FORCE 58</c:v>
+                </c:pt>
+                <c:pt idx="1">
+                  <c:v>NIKE MANOA LEATHER</c:v>
+                </c:pt>
+                <c:pt idx="2">
+                  <c:v>WMNS BENASSI JDI</c:v>
+                </c:pt>
+                <c:pt idx="3">
+                  <c:v>JORDAN TRUE FLIGHT (MS)</c:v>
+                </c:pt>
+                <c:pt idx="4">
+                  <c:v>AIR JORDAN 1 LOW SE (MS/WS)</c:v>
+                </c:pt>
+              </c:strCache>
+            </c:strRef>
+          </c:cat>
+          <c:val>
+            <c:numRef>
+              <c:f>'HFPA'!$P$22:$P$26</c:f>
+              <c:numCache>
+                <c:formatCode>0.00%</c:formatCode>
+                <c:ptCount val="5"/>
+                <c:pt idx="2">
+                  <c:v>0.120712</c:v>
+                </c:pt>
+              </c:numCache>
+            </c:numRef>
+          </c:val>
+        </c:ser>
+        <c:ser>
+          <c:idx val="4"/>
+          <c:order val="4"/>
+          <c:tx>
+            <c:strRef>
+              <c:f>'HFPA'!$Q$21</c:f>
+              <c:strCache>
+                <c:ptCount val="1"/>
+                <c:pt idx="0">
+                  <c:v>Wrinkle bottom</c:v>
+                </c:pt>
+              </c:strCache>
+            </c:strRef>
+          </c:tx>
+          <c:spPr>
+            <a:solidFill>
+              <a:srgbClr val="FAC090"/>
             </a:solidFill>
             <a:ln>
               <a:noFill/>
@@ -7842,35 +7879,127 @@
           </c:dLbls>
           <c:cat>
             <c:strRef>
-              <c:f>'Current month'!$L$22:$L$26</c:f>
+              <c:f>'HFPA'!$L$22:$L$26</c:f>
               <c:strCache>
                 <c:ptCount val="5"/>
                 <c:pt idx="0">
-                  <c:v>NIKE AIR WINFLO 12 (MS/WS)</c:v>
+                  <c:v>NIKE SB FORCE 58</c:v>
                 </c:pt>
                 <c:pt idx="1">
-                  <c:v>JORDAN SPIZIKE LOW (GS)</c:v>
+                  <c:v>NIKE MANOA LEATHER</c:v>
                 </c:pt>
                 <c:pt idx="2">
-                  <c:v>NIKE SB FORCE 58</c:v>
+                  <c:v>WMNS BENASSI JDI</c:v>
                 </c:pt>
                 <c:pt idx="3">
+                  <c:v>JORDAN TRUE FLIGHT (MS)</c:v>
+                </c:pt>
+                <c:pt idx="4">
                   <c:v>AIR JORDAN 1 LOW SE (MS/WS)</c:v>
-                </c:pt>
-                <c:pt idx="4">
-                  <c:v>WMNS BENASSI JDI</c:v>
                 </c:pt>
               </c:strCache>
             </c:strRef>
           </c:cat>
           <c:val>
             <c:numRef>
-              <c:f>'Current month'!$R$22:$R$26</c:f>
+              <c:f>'HFPA'!$Q$22:$Q$26</c:f>
               <c:numCache>
                 <c:formatCode>0.00%</c:formatCode>
                 <c:ptCount val="5"/>
+                <c:pt idx="3">
+                  <c:v>0.101979</c:v>
+                </c:pt>
+              </c:numCache>
+            </c:numRef>
+          </c:val>
+        </c:ser>
+        <c:ser>
+          <c:idx val="5"/>
+          <c:order val="5"/>
+          <c:tx>
+            <c:strRef>
+              <c:f>'HFPA'!$R$21</c:f>
+              <c:strCache>
+                <c:ptCount val="1"/>
+                <c:pt idx="0">
+                  <c:v>Over buffing</c:v>
+                </c:pt>
+              </c:strCache>
+            </c:strRef>
+          </c:tx>
+          <c:spPr>
+            <a:solidFill>
+              <a:srgbClr val="953735"/>
+            </a:solidFill>
+            <a:ln>
+              <a:noFill/>
+            </a:ln>
+          </c:spPr>
+          <c:invertIfNegative val="0"/>
+          <c:dLbls>
+            <c:spPr>
+              <a:noFill/>
+              <a:ln>
+                <a:noFill/>
+              </a:ln>
+            </c:spPr>
+            <c:txPr>
+              <a:bodyPr rot="0" spcFirstLastPara="1" vertOverflow="ellipsis" vert="horz" wrap="square" lIns="19050" tIns="9525" rIns="19050" bIns="9525" anchor="ctr" anchorCtr="1">
+                <a:spAutoFit/>
+              </a:bodyPr>
+              <a:lstStyle/>
+              <a:p>
+                <a:pPr>
+                  <a:defRPr lang="en-US" sz="700" b="1" i="0" baseline="0">
+                    <a:solidFill>
+                      <a:srgbClr val="FFFFFF"/>
+                    </a:solidFill>
+                    <a:latin typeface="Calibri"/>
+                  </a:defRPr>
+                </a:pPr>
+              </a:p>
+            </c:txPr>
+            <c:numFmt formatCode="0.00%" sourceLinked="0"/>
+            <c:dLblPos val="ctr"/>
+            <c:showLegendKey val="0"/>
+            <c:showVal val="1"/>
+            <c:showCatName val="0"/>
+            <c:showSerName val="0"/>
+            <c:showPercent val="0"/>
+            <c:showBubbleSize val="0"/>
+            <c:showLeaderLines val="0"/>
+          </c:dLbls>
+          <c:cat>
+            <c:strRef>
+              <c:f>'HFPA'!$L$22:$L$26</c:f>
+              <c:strCache>
+                <c:ptCount val="5"/>
+                <c:pt idx="0">
+                  <c:v>NIKE SB FORCE 58</c:v>
+                </c:pt>
+                <c:pt idx="1">
+                  <c:v>NIKE MANOA LEATHER</c:v>
+                </c:pt>
+                <c:pt idx="2">
+                  <c:v>WMNS BENASSI JDI</c:v>
+                </c:pt>
+                <c:pt idx="3">
+                  <c:v>JORDAN TRUE FLIGHT (MS)</c:v>
+                </c:pt>
                 <c:pt idx="4">
-                  <c:v>0.125621</c:v>
+                  <c:v>AIR JORDAN 1 LOW SE (MS/WS)</c:v>
+                </c:pt>
+              </c:strCache>
+            </c:strRef>
+          </c:cat>
+          <c:val>
+            <c:numRef>
+              <c:f>'HFPA'!$R$22:$R$26</c:f>
+              <c:numCache>
+                <c:formatCode>0.00%</c:formatCode>
+                <c:ptCount val="5"/>
+                <c:pt idx="1">
+                  <c:v>0.098379</c:v>
                 </c:pt>
               </c:numCache>
             </c:numRef>
@@ -7913,20 +8042,13 @@
                   </a:defRPr>
                 </a:pPr>
                 <a:r>
-                  <a:rPr lang="en-US" sz="800" u="sng" dirty="0" err="1">
+                  <a:rPr lang="en-US" sz="800" b="0" i="0" u="sng" baseline="0">
                     <a:solidFill>
                       <a:schemeClr val="tx1"/>
                     </a:solidFill>
+                    <a:latin typeface="+mn-lt"/>
                   </a:rPr>
-                  <a:t>Firsty</a:t>
-                </a:r>
-                <a:r>
-                  <a:rPr lang="en-US" sz="800" u="sng" baseline="0">
-                    <a:solidFill>
-                      <a:schemeClr val="tx1"/>
-                    </a:solidFill>
-                  </a:rPr>
-                  <a:t> prority: Cleanness</a:t>
+                  <a:t>First priority: Cleanness</a:t>
                 </a:r>
                 <a:endParaRPr lang="en-US" sz="800" u="sng">
                   <a:solidFill>
@@ -18229,7 +18351,7 @@
                 </a:solidFill>
                 <a:latin typeface="Arial"/>
               </a:rPr>
-              <a:t>Jun, 2026</a:t>
+              <a:t>Sep, 2026</a:t>
             </a:r>
             <a:endParaRPr lang="en-US" sz="2400" b="1" dirty="0">
               <a:solidFill>
@@ -18497,7 +18619,7 @@
                     </a:solidFill>
                     <a:latin typeface="Calibri Light"/>
                   </a:rPr>
-                  <a:t>VH: 229,614 prs</a:t>
+                  <a:t>VH: 191,303 prs</a:t>
                 </a:r>
                 <a:endParaRPr lang="en-US" sz="1300" dirty="0">
                   <a:solidFill>
@@ -18541,7 +18663,7 @@
                     </a:solidFill>
                     <a:latin typeface="Calibri Light"/>
                   </a:rPr>
-                  <a:t>VH2: 187,587 prs</a:t>
+                  <a:t>VH2: 175,514 prs</a:t>
                 </a:r>
                 <a:endParaRPr lang="en-US" sz="1300" dirty="0">
                   <a:solidFill>
@@ -18585,7 +18707,7 @@
                     </a:solidFill>
                     <a:latin typeface="Calibri Light"/>
                   </a:rPr>
-                  <a:t>JV: 91,617 prs</a:t>
+                  <a:t>JV: 97,919 prs</a:t>
                 </a:r>
                 <a:endParaRPr lang="en-US" sz="1300" dirty="0">
                   <a:solidFill>
@@ -18629,7 +18751,7 @@
                     </a:solidFill>
                     <a:latin typeface="Calibri Light"/>
                   </a:rPr>
-                  <a:t>JV2: 93,287 prs</a:t>
+                  <a:t>JV2: 79,079 prs</a:t>
                 </a:r>
                 <a:endParaRPr lang="en-US" sz="1300" dirty="0">
                   <a:solidFill>
@@ -18731,20 +18853,27 @@
             </a:fontRef>
           </p:style>
           <p:txBody>
-            <a:bodyPr wrap="none" lIns="0" tIns="0" rIns="0" bIns="0" rtlCol="0" anchor="ctr" anchorCtr="0">
+            <a:bodyPr wrap="square" lIns="0" tIns="0" rIns="0" bIns="0" rtlCol="0" anchor="ctr" anchorCtr="0">
               <a:spAutoFit/>
             </a:bodyPr>
             <a:lstStyle/>
             <a:p>
-              <a:pPr algn="ctr"/>
+              <a:pPr algn="ctr">
+                <a:spcBef>
+                  <a:spcPts val="0"/>
+                </a:spcBef>
+                <a:spcAft>
+                  <a:spcPts val="0"/>
+                </a:spcAft>
+              </a:pPr>
               <a:r>
-                <a:rPr sz="850" b="1">
+                <a:rPr sz="800" b="1">
                   <a:solidFill>
                     <a:srgbClr val="FFFFFF"/>
                   </a:solidFill>
                   <a:latin typeface="Calibri"/>
                 </a:rPr>
-                <a:t>Total pair produced</a:t>
+                <a:t>Total pair</a:t>
               </a:r>
               <a:endParaRPr lang="en-US" sz="900" b="1" dirty="0">
                 <a:solidFill>
@@ -18753,15 +18882,41 @@
               </a:endParaRPr>
             </a:p>
             <a:p>
-              <a:pPr algn="ctr"/>
+              <a:pPr algn="ctr">
+                <a:spcBef>
+                  <a:spcPts val="0"/>
+                </a:spcBef>
+                <a:spcAft>
+                  <a:spcPts val="100"/>
+                </a:spcAft>
+              </a:pPr>
               <a:r>
-                <a:rPr sz="1600" b="1">
+                <a:rPr sz="800" b="1">
                   <a:solidFill>
                     <a:srgbClr val="FFFFFF"/>
                   </a:solidFill>
                   <a:latin typeface="Calibri"/>
                 </a:rPr>
-                <a:t>~602K</a:t>
+                <a:t>produced</a:t>
+              </a:r>
+            </a:p>
+            <a:p>
+              <a:pPr algn="ctr">
+                <a:spcBef>
+                  <a:spcPts val="0"/>
+                </a:spcBef>
+                <a:spcAft>
+                  <a:spcPts val="0"/>
+                </a:spcAft>
+              </a:pPr>
+              <a:r>
+                <a:rPr sz="1500" b="1">
+                  <a:solidFill>
+                    <a:srgbClr val="FFFFFF"/>
+                  </a:solidFill>
+                  <a:latin typeface="Calibri"/>
+                </a:rPr>
+                <a:t>~544K</a:t>
               </a:r>
             </a:p>
           </p:txBody>
@@ -18889,7 +19044,7 @@
                     </a:solidFill>
                     <a:latin typeface="Calibri Light"/>
                   </a:rPr>
-                  <a:t>VH: 35,819 prs</a:t>
+                  <a:t>VH: 30,535 prs</a:t>
                 </a:r>
                 <a:endParaRPr lang="en-US" sz="1300" dirty="0">
                   <a:solidFill>
@@ -18933,7 +19088,7 @@
                     </a:solidFill>
                     <a:latin typeface="Calibri Light"/>
                   </a:rPr>
-                  <a:t>VH2: 26,824 prs</a:t>
+                  <a:t>VH2: 25,464 prs</a:t>
                 </a:r>
                 <a:endParaRPr lang="en-US" sz="1300" dirty="0">
                   <a:solidFill>
@@ -18977,7 +19132,7 @@
                     </a:solidFill>
                     <a:latin typeface="Calibri Light"/>
                   </a:rPr>
-                  <a:t>JV: 9,379 prs</a:t>
+                  <a:t>JV: 12,584 prs</a:t>
                 </a:r>
                 <a:endParaRPr lang="en-US" sz="1300" dirty="0">
                   <a:solidFill>
@@ -19021,7 +19176,7 @@
                     </a:solidFill>
                     <a:latin typeface="Calibri Light"/>
                   </a:rPr>
-                  <a:t>JV2: 5,475 prs</a:t>
+                  <a:t>JV2: 4,580 prs</a:t>
                 </a:r>
                 <a:endParaRPr lang="en-US" sz="1300" dirty="0">
                   <a:solidFill>
@@ -19154,7 +19309,7 @@
                   </a:solidFill>
                   <a:latin typeface="Calibri"/>
                 </a:rPr>
-                <a:t>~77K</a:t>
+                <a:t>~73K</a:t>
               </a:r>
             </a:p>
           </p:txBody>
@@ -19486,7 +19641,7 @@
                 </a:solidFill>
                 <a:latin typeface="Calibri"/>
               </a:rPr>
-              <a:t>15.60%</a:t>
+              <a:t>15.96%</a:t>
             </a:r>
           </a:p>
         </p:txBody>
@@ -19635,7 +19790,7 @@
                 </a:solidFill>
                 <a:latin typeface="Calibri"/>
               </a:rPr>
-              <a:t>14.30%</a:t>
+              <a:t>14.51%</a:t>
             </a:r>
           </a:p>
         </p:txBody>
@@ -19783,7 +19938,7 @@
                 </a:solidFill>
                 <a:latin typeface="Calibri"/>
               </a:rPr>
-              <a:t>10.24%</a:t>
+              <a:t>12.85%</a:t>
             </a:r>
           </a:p>
         </p:txBody>
@@ -19864,7 +20019,7 @@
                 </a:solidFill>
                 <a:latin typeface="Calibri"/>
               </a:rPr>
-              <a:t>5.87%</a:t>
+              <a:t>5.79%</a:t>
             </a:r>
           </a:p>
         </p:txBody>
@@ -20198,51 +20353,6 @@
           </a:graphicData>
         </a:graphic>
       </p:graphicFrame>
-      <p:sp>
-        <p:nvSpPr>
-          <p:cNvPr id="56" name="Rectangle 55"/>
-          <p:cNvSpPr/>
-          <p:nvPr/>
-        </p:nvSpPr>
-        <p:spPr>
-          <a:xfrm>
-            <a:off x="12192000" y="1491916"/>
-            <a:ext cx="1581752" cy="1318661"/>
-          </a:xfrm>
-          <a:prstGeom prst="rect">
-            <a:avLst/>
-          </a:prstGeom>
-        </p:spPr>
-        <p:style>
-          <a:lnRef idx="2">
-            <a:schemeClr val="accent1">
-              <a:shade val="50000"/>
-            </a:schemeClr>
-          </a:lnRef>
-          <a:fillRef idx="1">
-            <a:schemeClr val="accent1"/>
-          </a:fillRef>
-          <a:effectRef idx="0">
-            <a:schemeClr val="accent1"/>
-          </a:effectRef>
-          <a:fontRef idx="minor">
-            <a:schemeClr val="lt1"/>
-          </a:fontRef>
-        </p:style>
-        <p:txBody>
-          <a:bodyPr rtlCol="0" anchor="ctr" wrap="square"/>
-          <a:lstStyle/>
-          <a:p>
-            <a:r>
-              <a:rPr lang="en-US" sz="950">
-                <a:latin typeface="Calibri"/>
-              </a:rPr>
-              <a:t>Lưu ý về mức độ ưu tiên cải thiện lỗi: ưu tiên lỗi đó có nhiều model nhất sau đó sẽ xét tỷ lệ phần trăm</a:t>
-            </a:r>
-            <a:endParaRPr lang="vi-VN" sz="1400"/>
-          </a:p>
-        </p:txBody>
-      </p:sp>
       <p:pic>
         <p:nvPicPr>
           <p:cNvPr id="199" name="Picture 2" descr="defect_legend_rendered.png"/>
@@ -20260,7 +20370,7 @@
         <p:spPr>
           <a:xfrm>
             <a:off x="8588371" y="580000"/>
-            <a:ext cx="2855916" cy="760000"/>
+            <a:ext cx="2855916" cy="734378"/>
           </a:xfrm>
           <a:prstGeom prst="rect">
             <a:avLst/>

</xml_diff>